<commit_message>
test: add final-file connector checks and freeze execution replay inputs
</commit_message>
<xml_diff>
--- a/experiments/university-skin-pilot/stability-01/red-b/round-01/deck.pptx
+++ b/experiments/university-skin-pilot/stability-01/red-b/round-01/deck.pptx
@@ -2,23 +2,23 @@
 <file path=ppt/presentation.xml><?xml version="1.0" encoding="utf-8"?>
 <p:presentation xmlns:p="http://schemas.openxmlformats.org/presentationml/2006/main">
   <p:sldMasterIdLst>
-    <p:sldMasterId xmlns:r="http://schemas.openxmlformats.org/officeDocument/2006/relationships" id="2147483648" r:id="R5d4c3d7706ad4277"/>
+    <p:sldMasterId xmlns:r="http://schemas.openxmlformats.org/officeDocument/2006/relationships" id="2147483648" r:id="R1426b8a96f4f4541"/>
   </p:sldMasterIdLst>
   <p:notesMasterIdLst>
-    <p:notesMasterId xmlns:r="http://schemas.openxmlformats.org/officeDocument/2006/relationships" r:id="R170ea681543f44ec"/>
+    <p:notesMasterId xmlns:r="http://schemas.openxmlformats.org/officeDocument/2006/relationships" r:id="R7d5920b3dcd54aec"/>
   </p:notesMasterIdLst>
   <p:sldIdLst>
-    <p:sldId xmlns:r="http://schemas.openxmlformats.org/officeDocument/2006/relationships" id="256" r:id="Reaa22b1a3e0f40d9"/>
-    <p:sldId xmlns:r="http://schemas.openxmlformats.org/officeDocument/2006/relationships" id="257" r:id="R8478db79a6744921"/>
-    <p:sldId xmlns:r="http://schemas.openxmlformats.org/officeDocument/2006/relationships" id="258" r:id="R558564b223ac4a13"/>
-    <p:sldId xmlns:r="http://schemas.openxmlformats.org/officeDocument/2006/relationships" id="259" r:id="R39151a0e19b247fa"/>
-    <p:sldId xmlns:r="http://schemas.openxmlformats.org/officeDocument/2006/relationships" id="260" r:id="R310fd84aec72444b"/>
-    <p:sldId xmlns:r="http://schemas.openxmlformats.org/officeDocument/2006/relationships" id="261" r:id="R977e81f9aacd48b7"/>
-    <p:sldId xmlns:r="http://schemas.openxmlformats.org/officeDocument/2006/relationships" id="262" r:id="R69d1f0440d4f4edf"/>
-    <p:sldId xmlns:r="http://schemas.openxmlformats.org/officeDocument/2006/relationships" id="263" r:id="R6f0268703d5b4dcf"/>
-    <p:sldId xmlns:r="http://schemas.openxmlformats.org/officeDocument/2006/relationships" id="264" r:id="R0f7111b7c7924b96"/>
-    <p:sldId xmlns:r="http://schemas.openxmlformats.org/officeDocument/2006/relationships" id="265" r:id="Rb38a887ae47b4e5e"/>
-    <p:sldId xmlns:r="http://schemas.openxmlformats.org/officeDocument/2006/relationships" id="266" r:id="R5c8455c0284e49c5"/>
+    <p:sldId xmlns:r="http://schemas.openxmlformats.org/officeDocument/2006/relationships" id="256" r:id="R641b90d3ff4f43f3"/>
+    <p:sldId xmlns:r="http://schemas.openxmlformats.org/officeDocument/2006/relationships" id="257" r:id="Rca629752a58a4cae"/>
+    <p:sldId xmlns:r="http://schemas.openxmlformats.org/officeDocument/2006/relationships" id="258" r:id="R9ed0f2e30ce44ba2"/>
+    <p:sldId xmlns:r="http://schemas.openxmlformats.org/officeDocument/2006/relationships" id="259" r:id="R75ee9a84005b4249"/>
+    <p:sldId xmlns:r="http://schemas.openxmlformats.org/officeDocument/2006/relationships" id="260" r:id="R578df19fa1fd44d6"/>
+    <p:sldId xmlns:r="http://schemas.openxmlformats.org/officeDocument/2006/relationships" id="261" r:id="R0163e918bb464c80"/>
+    <p:sldId xmlns:r="http://schemas.openxmlformats.org/officeDocument/2006/relationships" id="262" r:id="R93f9171940fb43b7"/>
+    <p:sldId xmlns:r="http://schemas.openxmlformats.org/officeDocument/2006/relationships" id="263" r:id="R7d0cf205027b4a76"/>
+    <p:sldId xmlns:r="http://schemas.openxmlformats.org/officeDocument/2006/relationships" id="264" r:id="Ra3418d7d7263446b"/>
+    <p:sldId xmlns:r="http://schemas.openxmlformats.org/officeDocument/2006/relationships" id="265" r:id="Rb6f7288e611341f2"/>
+    <p:sldId xmlns:r="http://schemas.openxmlformats.org/officeDocument/2006/relationships" id="266" r:id="R25df8cf39b454883"/>
   </p:sldIdLst>
   <p:sldSz cx="12192000" cy="6858000"/>
   <p:notesSz cx="6858000" cy="9144000"/>
@@ -1220,7 +1220,7 @@
   </p:cSld>
   <p:clrMap bg1="lt1" tx1="dk1" bg2="lt2" tx2="dk2" accent1="accent1" accent2="accent2" accent3="accent3" accent4="accent4" accent5="accent5" accent6="accent6" hlink="hlink" folHlink="folHlink"/>
   <p:sldLayoutIdLst>
-    <p:sldLayoutId xmlns:r="http://schemas.openxmlformats.org/officeDocument/2006/relationships" id="2147483649" r:id="Ra493a86391cf43a9"/>
+    <p:sldLayoutId xmlns:r="http://schemas.openxmlformats.org/officeDocument/2006/relationships" id="2147483649" r:id="Reb1e314a3463489a"/>
   </p:sldLayoutIdLst>
   <p:txStyles>
     <p:titleStyle>
@@ -1771,7 +1771,7 @@
           <p:cNvPr id="12" name="cover-band">
             <a:extLst xmlns:a="http://schemas.openxmlformats.org/drawingml/2006/main">
               <a:ext uri="{FF2B5EF4-FFF2-40B4-BE49-F238E27FC236}">
-                <a16:creationId xmlns:a16="http://schemas.microsoft.com/office/drawing/2014/main" id="{38A032E3-690F-4A21-8777-5260E791AD54}"/>
+                <a16:creationId xmlns:a16="http://schemas.microsoft.com/office/drawing/2014/main" id="{3DC882F9-F8DB-48C2-9F44-459B34357F54}"/>
               </a:ext>
             </a:extLst>
           </p:cNvPr>
@@ -1802,7 +1802,7 @@
           <p:cNvPr id="2" name="cover-kicker">
             <a:extLst xmlns:a="http://schemas.openxmlformats.org/drawingml/2006/main">
               <a:ext uri="{FF2B5EF4-FFF2-40B4-BE49-F238E27FC236}">
-                <a16:creationId xmlns:a16="http://schemas.microsoft.com/office/drawing/2014/main" id="{ABBB7539-E06D-421C-93B6-41CE530928B0}"/>
+                <a16:creationId xmlns:a16="http://schemas.microsoft.com/office/drawing/2014/main" id="{BF716032-7003-404A-AE7B-C16F55394012}"/>
               </a:ext>
             </a:extLst>
           </p:cNvPr>
@@ -1864,7 +1864,7 @@
           <p:cNvPr id="3" name="cover-title">
             <a:extLst xmlns:a="http://schemas.openxmlformats.org/drawingml/2006/main">
               <a:ext uri="{FF2B5EF4-FFF2-40B4-BE49-F238E27FC236}">
-                <a16:creationId xmlns:a16="http://schemas.microsoft.com/office/drawing/2014/main" id="{755A453B-A085-4241-9934-C8D476916748}"/>
+                <a16:creationId xmlns:a16="http://schemas.microsoft.com/office/drawing/2014/main" id="{B78B8BB7-4B4B-43D6-A942-32364A27CFE1}"/>
               </a:ext>
             </a:extLst>
           </p:cNvPr>
@@ -1953,7 +1953,7 @@
           <p:cNvPr id="4" name="cover-sub">
             <a:extLst xmlns:a="http://schemas.openxmlformats.org/drawingml/2006/main">
               <a:ext uri="{FF2B5EF4-FFF2-40B4-BE49-F238E27FC236}">
-                <a16:creationId xmlns:a16="http://schemas.microsoft.com/office/drawing/2014/main" id="{1820F8D3-8E51-4C17-A911-06ADE99A75E1}"/>
+                <a16:creationId xmlns:a16="http://schemas.microsoft.com/office/drawing/2014/main" id="{12C16854-B4FD-4F23-AC77-8358790BF449}"/>
               </a:ext>
             </a:extLst>
           </p:cNvPr>
@@ -2015,7 +2015,7 @@
           <p:cNvPr id="5" name="cover-rule">
             <a:extLst xmlns:a="http://schemas.openxmlformats.org/drawingml/2006/main">
               <a:ext uri="{FF2B5EF4-FFF2-40B4-BE49-F238E27FC236}">
-                <a16:creationId xmlns:a16="http://schemas.microsoft.com/office/drawing/2014/main" id="{E70E7257-40AD-455B-B852-6C61523ED762}"/>
+                <a16:creationId xmlns:a16="http://schemas.microsoft.com/office/drawing/2014/main" id="{31D88FE7-728F-4DF3-BFE8-5F79A23BF5B9}"/>
               </a:ext>
             </a:extLst>
           </p:cNvPr>
@@ -2048,7 +2048,7 @@
           <p:cNvPr id="6" name="cover-foot">
             <a:extLst xmlns:a="http://schemas.openxmlformats.org/drawingml/2006/main">
               <a:ext uri="{FF2B5EF4-FFF2-40B4-BE49-F238E27FC236}">
-                <a16:creationId xmlns:a16="http://schemas.microsoft.com/office/drawing/2014/main" id="{8407BC08-952B-4479-AD9E-6D64A9C84CAA}"/>
+                <a16:creationId xmlns:a16="http://schemas.microsoft.com/office/drawing/2014/main" id="{5579B171-2762-41BE-BCE6-71507EF7083D}"/>
               </a:ext>
             </a:extLst>
           </p:cNvPr>
@@ -2110,7 +2110,7 @@
           <p:cNvPr id="7" name="cover-note">
             <a:extLst xmlns:a="http://schemas.openxmlformats.org/drawingml/2006/main">
               <a:ext uri="{FF2B5EF4-FFF2-40B4-BE49-F238E27FC236}">
-                <a16:creationId xmlns:a16="http://schemas.microsoft.com/office/drawing/2014/main" id="{5B7F7397-1F63-4F28-A24C-2554B9C0B003}"/>
+                <a16:creationId xmlns:a16="http://schemas.microsoft.com/office/drawing/2014/main" id="{ED5261C2-A54A-454A-8719-5B54E4044445}"/>
               </a:ext>
             </a:extLst>
           </p:cNvPr>
@@ -2172,7 +2172,7 @@
           <p:cNvPr id="8" name="cover-node">
             <a:extLst xmlns:a="http://schemas.openxmlformats.org/drawingml/2006/main">
               <a:ext uri="{FF2B5EF4-FFF2-40B4-BE49-F238E27FC236}">
-                <a16:creationId xmlns:a16="http://schemas.microsoft.com/office/drawing/2014/main" id="{8229B47B-1EEB-4881-8A4E-D56BC82346CC}"/>
+                <a16:creationId xmlns:a16="http://schemas.microsoft.com/office/drawing/2014/main" id="{7CBD908C-843C-4EFD-AB18-7360B07DBFB7}"/>
               </a:ext>
             </a:extLst>
           </p:cNvPr>
@@ -2207,7 +2207,7 @@
           <p:cNvPr id="9" name="cover-node-title">
             <a:extLst xmlns:a="http://schemas.openxmlformats.org/drawingml/2006/main">
               <a:ext uri="{FF2B5EF4-FFF2-40B4-BE49-F238E27FC236}">
-                <a16:creationId xmlns:a16="http://schemas.microsoft.com/office/drawing/2014/main" id="{32189C81-0E55-492A-97DC-665EE4FC6CBD}"/>
+                <a16:creationId xmlns:a16="http://schemas.microsoft.com/office/drawing/2014/main" id="{D5F3A1A9-F712-4628-90DF-D57818955851}"/>
               </a:ext>
             </a:extLst>
           </p:cNvPr>
@@ -2269,7 +2269,7 @@
           <p:cNvPr id="10" name="cover-node-sub">
             <a:extLst xmlns:a="http://schemas.openxmlformats.org/drawingml/2006/main">
               <a:ext uri="{FF2B5EF4-FFF2-40B4-BE49-F238E27FC236}">
-                <a16:creationId xmlns:a16="http://schemas.microsoft.com/office/drawing/2014/main" id="{30861F0E-3BA7-4D45-8075-772C2A10A5FC}"/>
+                <a16:creationId xmlns:a16="http://schemas.microsoft.com/office/drawing/2014/main" id="{CD81024C-848C-473A-9B54-3C1E622A0038}"/>
               </a:ext>
             </a:extLst>
           </p:cNvPr>
@@ -2331,7 +2331,7 @@
           <p:cNvPr id="11" name="cover-page">
             <a:extLst xmlns:a="http://schemas.openxmlformats.org/drawingml/2006/main">
               <a:ext uri="{FF2B5EF4-FFF2-40B4-BE49-F238E27FC236}">
-                <a16:creationId xmlns:a16="http://schemas.microsoft.com/office/drawing/2014/main" id="{0ACFB373-C562-4000-94FA-EFE3E0C2A822}"/>
+                <a16:creationId xmlns:a16="http://schemas.microsoft.com/office/drawing/2014/main" id="{D991B2D0-A515-491D-8BCA-1B4278D73B9C}"/>
               </a:ext>
             </a:extLst>
           </p:cNvPr>
@@ -2391,7 +2391,7 @@
     </p:spTree>
     <p:extLst>
       <p:ext uri="{BB962C8B-B14F-4D97-AF65-F5344CB8AC3E}">
-        <p14:creationId xmlns:p14="http://schemas.microsoft.com/office/powerpoint/2010/main" val="1132346218"/>
+        <p14:creationId xmlns:p14="http://schemas.microsoft.com/office/powerpoint/2010/main" val="340398799"/>
       </p:ext>
     </p:extLst>
   </p:cSld>
@@ -2422,7 +2422,7 @@
           <p:cNvPr id="25" name="kicker">
             <a:extLst xmlns:a="http://schemas.openxmlformats.org/drawingml/2006/main">
               <a:ext uri="{FF2B5EF4-FFF2-40B4-BE49-F238E27FC236}">
-                <a16:creationId xmlns:a16="http://schemas.microsoft.com/office/drawing/2014/main" id="{41B5E5B0-C0EC-42D2-B6C2-7121C7C7FD15}"/>
+                <a16:creationId xmlns:a16="http://schemas.microsoft.com/office/drawing/2014/main" id="{3AB15EC0-7699-4580-A883-AEA6ED0D61B5}"/>
               </a:ext>
             </a:extLst>
           </p:cNvPr>
@@ -2484,7 +2484,7 @@
           <p:cNvPr id="2" name="title">
             <a:extLst xmlns:a="http://schemas.openxmlformats.org/drawingml/2006/main">
               <a:ext uri="{FF2B5EF4-FFF2-40B4-BE49-F238E27FC236}">
-                <a16:creationId xmlns:a16="http://schemas.microsoft.com/office/drawing/2014/main" id="{933888B3-838D-46B3-A4BD-00BA8A0513CB}"/>
+                <a16:creationId xmlns:a16="http://schemas.microsoft.com/office/drawing/2014/main" id="{2639F910-FD38-42C5-B2CC-AEC24C74A8DC}"/>
               </a:ext>
             </a:extLst>
           </p:cNvPr>
@@ -2546,7 +2546,7 @@
           <p:cNvPr id="3" name="title-rule">
             <a:extLst xmlns:a="http://schemas.openxmlformats.org/drawingml/2006/main">
               <a:ext uri="{FF2B5EF4-FFF2-40B4-BE49-F238E27FC236}">
-                <a16:creationId xmlns:a16="http://schemas.microsoft.com/office/drawing/2014/main" id="{8A4E129A-09AD-49B1-BE2F-2FC9B8F38456}"/>
+                <a16:creationId xmlns:a16="http://schemas.microsoft.com/office/drawing/2014/main" id="{35C411A8-BA43-4759-8C81-A46FE49597D3}"/>
               </a:ext>
             </a:extLst>
           </p:cNvPr>
@@ -2579,7 +2579,7 @@
           <p:cNvPr id="4" name="footer-source">
             <a:extLst xmlns:a="http://schemas.openxmlformats.org/drawingml/2006/main">
               <a:ext uri="{FF2B5EF4-FFF2-40B4-BE49-F238E27FC236}">
-                <a16:creationId xmlns:a16="http://schemas.microsoft.com/office/drawing/2014/main" id="{0C4784C2-07CD-4E4B-AB6B-5AF91DA10259}"/>
+                <a16:creationId xmlns:a16="http://schemas.microsoft.com/office/drawing/2014/main" id="{31B11A28-B91A-4DCA-9B32-7ABC0DD35C1A}"/>
               </a:ext>
             </a:extLst>
           </p:cNvPr>
@@ -2641,7 +2641,7 @@
           <p:cNvPr id="5" name="footer-page">
             <a:extLst xmlns:a="http://schemas.openxmlformats.org/drawingml/2006/main">
               <a:ext uri="{FF2B5EF4-FFF2-40B4-BE49-F238E27FC236}">
-                <a16:creationId xmlns:a16="http://schemas.microsoft.com/office/drawing/2014/main" id="{8F1F4DBB-4E91-43B3-AFAE-83D18E2595AA}"/>
+                <a16:creationId xmlns:a16="http://schemas.microsoft.com/office/drawing/2014/main" id="{ECD13535-0C38-46A7-A97D-8BA5D9EEC98F}"/>
               </a:ext>
             </a:extLst>
           </p:cNvPr>
@@ -2703,7 +2703,7 @@
           <p:cNvPr id="6" name="lead">
             <a:extLst xmlns:a="http://schemas.openxmlformats.org/drawingml/2006/main">
               <a:ext uri="{FF2B5EF4-FFF2-40B4-BE49-F238E27FC236}">
-                <a16:creationId xmlns:a16="http://schemas.microsoft.com/office/drawing/2014/main" id="{44D0DB61-919C-4539-BEA7-28097A578B6E}"/>
+                <a16:creationId xmlns:a16="http://schemas.microsoft.com/office/drawing/2014/main" id="{BBE74524-BA6E-418B-833F-74C05FDDD187}"/>
               </a:ext>
             </a:extLst>
           </p:cNvPr>
@@ -2765,7 +2765,7 @@
           <p:cNvPr id="7" name="result-0">
             <a:extLst xmlns:a="http://schemas.openxmlformats.org/drawingml/2006/main">
               <a:ext uri="{FF2B5EF4-FFF2-40B4-BE49-F238E27FC236}">
-                <a16:creationId xmlns:a16="http://schemas.microsoft.com/office/drawing/2014/main" id="{57DCFCBC-1EB0-40DE-944D-8408903DE5C8}"/>
+                <a16:creationId xmlns:a16="http://schemas.microsoft.com/office/drawing/2014/main" id="{C9CBDDFF-6B1C-4AC8-947F-C97D246051F0}"/>
               </a:ext>
             </a:extLst>
           </p:cNvPr>
@@ -2800,7 +2800,7 @@
           <p:cNvPr id="8" name="result-0-title">
             <a:extLst xmlns:a="http://schemas.openxmlformats.org/drawingml/2006/main">
               <a:ext uri="{FF2B5EF4-FFF2-40B4-BE49-F238E27FC236}">
-                <a16:creationId xmlns:a16="http://schemas.microsoft.com/office/drawing/2014/main" id="{F6F8F86D-68E0-4FDE-8D87-95C92B0123BF}"/>
+                <a16:creationId xmlns:a16="http://schemas.microsoft.com/office/drawing/2014/main" id="{F2FD1B21-BF67-4B08-A2BF-6249F836151A}"/>
               </a:ext>
             </a:extLst>
           </p:cNvPr>
@@ -2862,7 +2862,7 @@
           <p:cNvPr id="9" name="result-0-num">
             <a:extLst xmlns:a="http://schemas.openxmlformats.org/drawingml/2006/main">
               <a:ext uri="{FF2B5EF4-FFF2-40B4-BE49-F238E27FC236}">
-                <a16:creationId xmlns:a16="http://schemas.microsoft.com/office/drawing/2014/main" id="{8256D5B2-5950-4C7E-B765-F94C5F2C6FE7}"/>
+                <a16:creationId xmlns:a16="http://schemas.microsoft.com/office/drawing/2014/main" id="{4C0E06FB-370F-4D57-A431-DF32B09831A4}"/>
               </a:ext>
             </a:extLst>
           </p:cNvPr>
@@ -2924,7 +2924,7 @@
           <p:cNvPr id="10" name="result-0-copy">
             <a:extLst xmlns:a="http://schemas.openxmlformats.org/drawingml/2006/main">
               <a:ext uri="{FF2B5EF4-FFF2-40B4-BE49-F238E27FC236}">
-                <a16:creationId xmlns:a16="http://schemas.microsoft.com/office/drawing/2014/main" id="{9421D77E-5A9E-40CF-BA18-EFFAE58BBC09}"/>
+                <a16:creationId xmlns:a16="http://schemas.microsoft.com/office/drawing/2014/main" id="{F9E36909-1031-4B53-B96B-372D71B53B8C}"/>
               </a:ext>
             </a:extLst>
           </p:cNvPr>
@@ -3013,7 +3013,7 @@
           <p:cNvPr id="11" name="result-1">
             <a:extLst xmlns:a="http://schemas.openxmlformats.org/drawingml/2006/main">
               <a:ext uri="{FF2B5EF4-FFF2-40B4-BE49-F238E27FC236}">
-                <a16:creationId xmlns:a16="http://schemas.microsoft.com/office/drawing/2014/main" id="{2B29CC36-E1F9-4EDB-8487-AE32EAC6BE25}"/>
+                <a16:creationId xmlns:a16="http://schemas.microsoft.com/office/drawing/2014/main" id="{1F8AB51D-49BF-41DA-8A8E-6FA2F84DC66D}"/>
               </a:ext>
             </a:extLst>
           </p:cNvPr>
@@ -3048,7 +3048,7 @@
           <p:cNvPr id="12" name="result-1-title">
             <a:extLst xmlns:a="http://schemas.openxmlformats.org/drawingml/2006/main">
               <a:ext uri="{FF2B5EF4-FFF2-40B4-BE49-F238E27FC236}">
-                <a16:creationId xmlns:a16="http://schemas.microsoft.com/office/drawing/2014/main" id="{0430EAEB-13B5-4C57-AA23-499537DCFC3D}"/>
+                <a16:creationId xmlns:a16="http://schemas.microsoft.com/office/drawing/2014/main" id="{DB380C81-82B4-4415-9424-FE4D7A037E87}"/>
               </a:ext>
             </a:extLst>
           </p:cNvPr>
@@ -3110,7 +3110,7 @@
           <p:cNvPr id="13" name="result-1-num">
             <a:extLst xmlns:a="http://schemas.openxmlformats.org/drawingml/2006/main">
               <a:ext uri="{FF2B5EF4-FFF2-40B4-BE49-F238E27FC236}">
-                <a16:creationId xmlns:a16="http://schemas.microsoft.com/office/drawing/2014/main" id="{12C5CA03-3729-4410-843D-73A641296E15}"/>
+                <a16:creationId xmlns:a16="http://schemas.microsoft.com/office/drawing/2014/main" id="{DFA7A0E6-E150-4C9C-83C1-F09E134033D7}"/>
               </a:ext>
             </a:extLst>
           </p:cNvPr>
@@ -3172,7 +3172,7 @@
           <p:cNvPr id="14" name="result-1-copy">
             <a:extLst xmlns:a="http://schemas.openxmlformats.org/drawingml/2006/main">
               <a:ext uri="{FF2B5EF4-FFF2-40B4-BE49-F238E27FC236}">
-                <a16:creationId xmlns:a16="http://schemas.microsoft.com/office/drawing/2014/main" id="{9185FE7B-81A4-4898-BC36-BC83C34A6835}"/>
+                <a16:creationId xmlns:a16="http://schemas.microsoft.com/office/drawing/2014/main" id="{38067924-59F7-4ED7-A5D1-D18EC2131ED1}"/>
               </a:ext>
             </a:extLst>
           </p:cNvPr>
@@ -3261,7 +3261,7 @@
           <p:cNvPr id="15" name="result-2">
             <a:extLst xmlns:a="http://schemas.openxmlformats.org/drawingml/2006/main">
               <a:ext uri="{FF2B5EF4-FFF2-40B4-BE49-F238E27FC236}">
-                <a16:creationId xmlns:a16="http://schemas.microsoft.com/office/drawing/2014/main" id="{480D740A-7DAE-4D48-92BD-34EE1C8091E7}"/>
+                <a16:creationId xmlns:a16="http://schemas.microsoft.com/office/drawing/2014/main" id="{33702541-4913-4EED-A2B5-A3626E9BE992}"/>
               </a:ext>
             </a:extLst>
           </p:cNvPr>
@@ -3296,7 +3296,7 @@
           <p:cNvPr id="16" name="result-2-title">
             <a:extLst xmlns:a="http://schemas.openxmlformats.org/drawingml/2006/main">
               <a:ext uri="{FF2B5EF4-FFF2-40B4-BE49-F238E27FC236}">
-                <a16:creationId xmlns:a16="http://schemas.microsoft.com/office/drawing/2014/main" id="{F3D217C9-0625-4024-AEC9-BDE7D4D4BD29}"/>
+                <a16:creationId xmlns:a16="http://schemas.microsoft.com/office/drawing/2014/main" id="{93AD40AA-EE55-440B-AF10-F46F7D451ADA}"/>
               </a:ext>
             </a:extLst>
           </p:cNvPr>
@@ -3358,7 +3358,7 @@
           <p:cNvPr id="17" name="result-2-num">
             <a:extLst xmlns:a="http://schemas.openxmlformats.org/drawingml/2006/main">
               <a:ext uri="{FF2B5EF4-FFF2-40B4-BE49-F238E27FC236}">
-                <a16:creationId xmlns:a16="http://schemas.microsoft.com/office/drawing/2014/main" id="{7A63FAA8-D63F-4584-99C9-98E36611276E}"/>
+                <a16:creationId xmlns:a16="http://schemas.microsoft.com/office/drawing/2014/main" id="{9FC77F7E-E33B-47A0-8627-A8E741277519}"/>
               </a:ext>
             </a:extLst>
           </p:cNvPr>
@@ -3420,7 +3420,7 @@
           <p:cNvPr id="18" name="result-2-copy">
             <a:extLst xmlns:a="http://schemas.openxmlformats.org/drawingml/2006/main">
               <a:ext uri="{FF2B5EF4-FFF2-40B4-BE49-F238E27FC236}">
-                <a16:creationId xmlns:a16="http://schemas.microsoft.com/office/drawing/2014/main" id="{AB58F23B-A258-4438-9E14-F4B5CBBBA94C}"/>
+                <a16:creationId xmlns:a16="http://schemas.microsoft.com/office/drawing/2014/main" id="{81F10B56-70A7-4959-AC39-496A88A3F959}"/>
               </a:ext>
             </a:extLst>
           </p:cNvPr>
@@ -3509,7 +3509,7 @@
           <p:cNvPr id="19" name="result-3">
             <a:extLst xmlns:a="http://schemas.openxmlformats.org/drawingml/2006/main">
               <a:ext uri="{FF2B5EF4-FFF2-40B4-BE49-F238E27FC236}">
-                <a16:creationId xmlns:a16="http://schemas.microsoft.com/office/drawing/2014/main" id="{69B4F898-2061-4E35-ABA8-35FD90BAF7E7}"/>
+                <a16:creationId xmlns:a16="http://schemas.microsoft.com/office/drawing/2014/main" id="{428215DC-279D-4677-A1AC-2DFFD868FACC}"/>
               </a:ext>
             </a:extLst>
           </p:cNvPr>
@@ -3542,7 +3542,7 @@
           <p:cNvPr id="20" name="result-3-title">
             <a:extLst xmlns:a="http://schemas.openxmlformats.org/drawingml/2006/main">
               <a:ext uri="{FF2B5EF4-FFF2-40B4-BE49-F238E27FC236}">
-                <a16:creationId xmlns:a16="http://schemas.microsoft.com/office/drawing/2014/main" id="{47CDF60E-6C41-49E2-AFA7-49648FC63B0A}"/>
+                <a16:creationId xmlns:a16="http://schemas.microsoft.com/office/drawing/2014/main" id="{54FBFC5E-BF2B-452B-928A-CA0342F7FE38}"/>
               </a:ext>
             </a:extLst>
           </p:cNvPr>
@@ -3604,7 +3604,7 @@
           <p:cNvPr id="21" name="result-3-num">
             <a:extLst xmlns:a="http://schemas.openxmlformats.org/drawingml/2006/main">
               <a:ext uri="{FF2B5EF4-FFF2-40B4-BE49-F238E27FC236}">
-                <a16:creationId xmlns:a16="http://schemas.microsoft.com/office/drawing/2014/main" id="{3769D658-A417-451E-9F89-CBD352F76D85}"/>
+                <a16:creationId xmlns:a16="http://schemas.microsoft.com/office/drawing/2014/main" id="{690A15C3-130E-4B41-ADBA-56A2AB7CB38F}"/>
               </a:ext>
             </a:extLst>
           </p:cNvPr>
@@ -3666,7 +3666,7 @@
           <p:cNvPr id="22" name="result-3-copy">
             <a:extLst xmlns:a="http://schemas.openxmlformats.org/drawingml/2006/main">
               <a:ext uri="{FF2B5EF4-FFF2-40B4-BE49-F238E27FC236}">
-                <a16:creationId xmlns:a16="http://schemas.microsoft.com/office/drawing/2014/main" id="{A40D5C21-6D3E-4C54-BD47-EF29ADE1554D}"/>
+                <a16:creationId xmlns:a16="http://schemas.microsoft.com/office/drawing/2014/main" id="{2CE32456-6FC4-4743-8DF4-A96104680B68}"/>
               </a:ext>
             </a:extLst>
           </p:cNvPr>
@@ -3755,7 +3755,7 @@
           <p:cNvPr id="23" name="result-note">
             <a:extLst xmlns:a="http://schemas.openxmlformats.org/drawingml/2006/main">
               <a:ext uri="{FF2B5EF4-FFF2-40B4-BE49-F238E27FC236}">
-                <a16:creationId xmlns:a16="http://schemas.microsoft.com/office/drawing/2014/main" id="{002924E4-6ACA-4E32-90B8-3066B4BFD0F1}"/>
+                <a16:creationId xmlns:a16="http://schemas.microsoft.com/office/drawing/2014/main" id="{B029C0B4-FE8B-4A10-A34D-FDFED5C8C174}"/>
               </a:ext>
             </a:extLst>
           </p:cNvPr>
@@ -3817,7 +3817,7 @@
           <p:cNvPr id="24" name="result-boundary">
             <a:extLst xmlns:a="http://schemas.openxmlformats.org/drawingml/2006/main">
               <a:ext uri="{FF2B5EF4-FFF2-40B4-BE49-F238E27FC236}">
-                <a16:creationId xmlns:a16="http://schemas.microsoft.com/office/drawing/2014/main" id="{633DBCC9-23B4-4BF5-B718-1353E6B44EE8}"/>
+                <a16:creationId xmlns:a16="http://schemas.microsoft.com/office/drawing/2014/main" id="{E34EF16C-3811-44B7-8CD9-DC9F337D1F27}"/>
               </a:ext>
             </a:extLst>
           </p:cNvPr>
@@ -3877,7 +3877,7 @@
     </p:spTree>
     <p:extLst>
       <p:ext uri="{BB962C8B-B14F-4D97-AF65-F5344CB8AC3E}">
-        <p14:creationId xmlns:p14="http://schemas.microsoft.com/office/powerpoint/2010/main" val="2146811193"/>
+        <p14:creationId xmlns:p14="http://schemas.microsoft.com/office/powerpoint/2010/main" val="2097515209"/>
       </p:ext>
     </p:extLst>
   </p:cSld>
@@ -3908,7 +3908,7 @@
           <p:cNvPr id="11" name="close-band">
             <a:extLst xmlns:a="http://schemas.openxmlformats.org/drawingml/2006/main">
               <a:ext uri="{FF2B5EF4-FFF2-40B4-BE49-F238E27FC236}">
-                <a16:creationId xmlns:a16="http://schemas.microsoft.com/office/drawing/2014/main" id="{EC35DD8B-9811-4FD9-A7E7-E5476E158B4A}"/>
+                <a16:creationId xmlns:a16="http://schemas.microsoft.com/office/drawing/2014/main" id="{DB18F412-07AF-41F0-98F7-6A9013339385}"/>
               </a:ext>
             </a:extLst>
           </p:cNvPr>
@@ -3939,7 +3939,7 @@
           <p:cNvPr id="2" name="close-kicker">
             <a:extLst xmlns:a="http://schemas.openxmlformats.org/drawingml/2006/main">
               <a:ext uri="{FF2B5EF4-FFF2-40B4-BE49-F238E27FC236}">
-                <a16:creationId xmlns:a16="http://schemas.microsoft.com/office/drawing/2014/main" id="{46299177-2DEC-4086-B7FF-A9C3375F6211}"/>
+                <a16:creationId xmlns:a16="http://schemas.microsoft.com/office/drawing/2014/main" id="{AF601A72-65D7-427F-86B3-6F7690EF38B1}"/>
               </a:ext>
             </a:extLst>
           </p:cNvPr>
@@ -4001,7 +4001,7 @@
           <p:cNvPr id="3" name="close-title">
             <a:extLst xmlns:a="http://schemas.openxmlformats.org/drawingml/2006/main">
               <a:ext uri="{FF2B5EF4-FFF2-40B4-BE49-F238E27FC236}">
-                <a16:creationId xmlns:a16="http://schemas.microsoft.com/office/drawing/2014/main" id="{DD8B6F6F-A8D0-4DEA-A749-B183B2BB309D}"/>
+                <a16:creationId xmlns:a16="http://schemas.microsoft.com/office/drawing/2014/main" id="{C8469467-972A-4F70-A029-2DB6189420FD}"/>
               </a:ext>
             </a:extLst>
           </p:cNvPr>
@@ -4063,7 +4063,7 @@
           <p:cNvPr id="4" name="close-rule">
             <a:extLst xmlns:a="http://schemas.openxmlformats.org/drawingml/2006/main">
               <a:ext uri="{FF2B5EF4-FFF2-40B4-BE49-F238E27FC236}">
-                <a16:creationId xmlns:a16="http://schemas.microsoft.com/office/drawing/2014/main" id="{D8E62859-A285-4CDB-88AD-63B8190105E0}"/>
+                <a16:creationId xmlns:a16="http://schemas.microsoft.com/office/drawing/2014/main" id="{FCEBF268-E57A-4916-8266-832C1DDEC93B}"/>
               </a:ext>
             </a:extLst>
           </p:cNvPr>
@@ -4096,7 +4096,7 @@
           <p:cNvPr id="5" name="close-quote">
             <a:extLst xmlns:a="http://schemas.openxmlformats.org/drawingml/2006/main">
               <a:ext uri="{FF2B5EF4-FFF2-40B4-BE49-F238E27FC236}">
-                <a16:creationId xmlns:a16="http://schemas.microsoft.com/office/drawing/2014/main" id="{72D282DC-FD91-4AAF-B72C-8B2B0204381A}"/>
+                <a16:creationId xmlns:a16="http://schemas.microsoft.com/office/drawing/2014/main" id="{A3AF259D-0560-4462-AA06-25DCBED7C039}"/>
               </a:ext>
             </a:extLst>
           </p:cNvPr>
@@ -4185,7 +4185,7 @@
           <p:cNvPr id="6" name="close-attrib">
             <a:extLst xmlns:a="http://schemas.openxmlformats.org/drawingml/2006/main">
               <a:ext uri="{FF2B5EF4-FFF2-40B4-BE49-F238E27FC236}">
-                <a16:creationId xmlns:a16="http://schemas.microsoft.com/office/drawing/2014/main" id="{0B951330-C831-4B14-A637-FFF11BEE2B53}"/>
+                <a16:creationId xmlns:a16="http://schemas.microsoft.com/office/drawing/2014/main" id="{F737BA5C-A633-4B5F-A231-C4414DE0BAC3}"/>
               </a:ext>
             </a:extLst>
           </p:cNvPr>
@@ -4247,7 +4247,7 @@
           <p:cNvPr id="7" name="close-strip">
             <a:extLst xmlns:a="http://schemas.openxmlformats.org/drawingml/2006/main">
               <a:ext uri="{FF2B5EF4-FFF2-40B4-BE49-F238E27FC236}">
-                <a16:creationId xmlns:a16="http://schemas.microsoft.com/office/drawing/2014/main" id="{85832E76-7178-4F88-88BF-82D3056AFAB4}"/>
+                <a16:creationId xmlns:a16="http://schemas.microsoft.com/office/drawing/2014/main" id="{12C0BFAE-342D-455B-A2B3-0531F4F69464}"/>
               </a:ext>
             </a:extLst>
           </p:cNvPr>
@@ -4280,7 +4280,7 @@
           <p:cNvPr id="8" name="close-strip-copy">
             <a:extLst xmlns:a="http://schemas.openxmlformats.org/drawingml/2006/main">
               <a:ext uri="{FF2B5EF4-FFF2-40B4-BE49-F238E27FC236}">
-                <a16:creationId xmlns:a16="http://schemas.microsoft.com/office/drawing/2014/main" id="{861D756A-48E0-4199-92B0-5BA4BF5CB5C5}"/>
+                <a16:creationId xmlns:a16="http://schemas.microsoft.com/office/drawing/2014/main" id="{898E6FA9-0CD3-453D-B8EE-8ABBACB4FDAE}"/>
               </a:ext>
             </a:extLst>
           </p:cNvPr>
@@ -4342,7 +4342,7 @@
           <p:cNvPr id="9" name="close-final">
             <a:extLst xmlns:a="http://schemas.openxmlformats.org/drawingml/2006/main">
               <a:ext uri="{FF2B5EF4-FFF2-40B4-BE49-F238E27FC236}">
-                <a16:creationId xmlns:a16="http://schemas.microsoft.com/office/drawing/2014/main" id="{A88867EE-617D-40F2-8EF8-1AA2BF76208F}"/>
+                <a16:creationId xmlns:a16="http://schemas.microsoft.com/office/drawing/2014/main" id="{3498BDBA-921C-4386-95E6-09ACEF226F99}"/>
               </a:ext>
             </a:extLst>
           </p:cNvPr>
@@ -4404,7 +4404,7 @@
           <p:cNvPr id="10" name="close-page">
             <a:extLst xmlns:a="http://schemas.openxmlformats.org/drawingml/2006/main">
               <a:ext uri="{FF2B5EF4-FFF2-40B4-BE49-F238E27FC236}">
-                <a16:creationId xmlns:a16="http://schemas.microsoft.com/office/drawing/2014/main" id="{387BAF4D-9F60-4D4F-A5E7-40DF07A5F5F6}"/>
+                <a16:creationId xmlns:a16="http://schemas.microsoft.com/office/drawing/2014/main" id="{7DD98DDF-58F3-4B5D-8547-7F39F67BC97A}"/>
               </a:ext>
             </a:extLst>
           </p:cNvPr>
@@ -4464,7 +4464,7 @@
     </p:spTree>
     <p:extLst>
       <p:ext uri="{BB962C8B-B14F-4D97-AF65-F5344CB8AC3E}">
-        <p14:creationId xmlns:p14="http://schemas.microsoft.com/office/powerpoint/2010/main" val="1770810580"/>
+        <p14:creationId xmlns:p14="http://schemas.microsoft.com/office/powerpoint/2010/main" val="91201158"/>
       </p:ext>
     </p:extLst>
   </p:cSld>
@@ -4495,7 +4495,7 @@
           <p:cNvPr id="19" name="kicker">
             <a:extLst xmlns:a="http://schemas.openxmlformats.org/drawingml/2006/main">
               <a:ext uri="{FF2B5EF4-FFF2-40B4-BE49-F238E27FC236}">
-                <a16:creationId xmlns:a16="http://schemas.microsoft.com/office/drawing/2014/main" id="{92DFDBB0-5AAB-412F-AE5D-86E7B2942D8E}"/>
+                <a16:creationId xmlns:a16="http://schemas.microsoft.com/office/drawing/2014/main" id="{E8487551-5091-4224-918D-5DCA10D252E4}"/>
               </a:ext>
             </a:extLst>
           </p:cNvPr>
@@ -4557,7 +4557,7 @@
           <p:cNvPr id="2" name="title">
             <a:extLst xmlns:a="http://schemas.openxmlformats.org/drawingml/2006/main">
               <a:ext uri="{FF2B5EF4-FFF2-40B4-BE49-F238E27FC236}">
-                <a16:creationId xmlns:a16="http://schemas.microsoft.com/office/drawing/2014/main" id="{9AB7B4B3-6564-4A97-9B87-FB39A301E48A}"/>
+                <a16:creationId xmlns:a16="http://schemas.microsoft.com/office/drawing/2014/main" id="{33F4FBF5-FA63-4507-931D-778B1A4B6088}"/>
               </a:ext>
             </a:extLst>
           </p:cNvPr>
@@ -4619,7 +4619,7 @@
           <p:cNvPr id="3" name="title-rule">
             <a:extLst xmlns:a="http://schemas.openxmlformats.org/drawingml/2006/main">
               <a:ext uri="{FF2B5EF4-FFF2-40B4-BE49-F238E27FC236}">
-                <a16:creationId xmlns:a16="http://schemas.microsoft.com/office/drawing/2014/main" id="{6052CD38-6959-418A-B339-DCC35FE5F0E8}"/>
+                <a16:creationId xmlns:a16="http://schemas.microsoft.com/office/drawing/2014/main" id="{DE857FEF-71C6-4536-8B0F-B0A476104DDA}"/>
               </a:ext>
             </a:extLst>
           </p:cNvPr>
@@ -4652,7 +4652,7 @@
           <p:cNvPr id="4" name="footer-source">
             <a:extLst xmlns:a="http://schemas.openxmlformats.org/drawingml/2006/main">
               <a:ext uri="{FF2B5EF4-FFF2-40B4-BE49-F238E27FC236}">
-                <a16:creationId xmlns:a16="http://schemas.microsoft.com/office/drawing/2014/main" id="{FDF23FFB-3089-4A76-BC56-0FF7388D8FEB}"/>
+                <a16:creationId xmlns:a16="http://schemas.microsoft.com/office/drawing/2014/main" id="{60B73CB8-569E-40A9-8074-80CEC49D1A2F}"/>
               </a:ext>
             </a:extLst>
           </p:cNvPr>
@@ -4714,7 +4714,7 @@
           <p:cNvPr id="5" name="footer-page">
             <a:extLst xmlns:a="http://schemas.openxmlformats.org/drawingml/2006/main">
               <a:ext uri="{FF2B5EF4-FFF2-40B4-BE49-F238E27FC236}">
-                <a16:creationId xmlns:a16="http://schemas.microsoft.com/office/drawing/2014/main" id="{B4E2743D-71A6-4FCF-80BE-18F08CC24527}"/>
+                <a16:creationId xmlns:a16="http://schemas.microsoft.com/office/drawing/2014/main" id="{D57080AF-87C0-4C79-B74E-7F4AE7308063}"/>
               </a:ext>
             </a:extLst>
           </p:cNvPr>
@@ -4776,7 +4776,7 @@
           <p:cNvPr id="6" name="lead">
             <a:extLst xmlns:a="http://schemas.openxmlformats.org/drawingml/2006/main">
               <a:ext uri="{FF2B5EF4-FFF2-40B4-BE49-F238E27FC236}">
-                <a16:creationId xmlns:a16="http://schemas.microsoft.com/office/drawing/2014/main" id="{EEF8D1E4-4CCE-45A9-AAF9-83CF0C7DDB63}"/>
+                <a16:creationId xmlns:a16="http://schemas.microsoft.com/office/drawing/2014/main" id="{8AA9B32D-8F0A-4699-B68B-77EA3C8CEF78}"/>
               </a:ext>
             </a:extLst>
           </p:cNvPr>
@@ -4838,7 +4838,7 @@
           <p:cNvPr id="7" name="high-group">
             <a:extLst xmlns:a="http://schemas.openxmlformats.org/drawingml/2006/main">
               <a:ext uri="{FF2B5EF4-FFF2-40B4-BE49-F238E27FC236}">
-                <a16:creationId xmlns:a16="http://schemas.microsoft.com/office/drawing/2014/main" id="{821BD9CA-73E3-4986-B855-20180845AF82}"/>
+                <a16:creationId xmlns:a16="http://schemas.microsoft.com/office/drawing/2014/main" id="{4BCB3BAB-7BF3-44F5-AA1C-48BF57C86B48}"/>
               </a:ext>
             </a:extLst>
           </p:cNvPr>
@@ -4873,7 +4873,7 @@
           <p:cNvPr id="8" name="high-title">
             <a:extLst xmlns:a="http://schemas.openxmlformats.org/drawingml/2006/main">
               <a:ext uri="{FF2B5EF4-FFF2-40B4-BE49-F238E27FC236}">
-                <a16:creationId xmlns:a16="http://schemas.microsoft.com/office/drawing/2014/main" id="{13FC017D-ECB3-402E-9CD1-39CB7880EE2A}"/>
+                <a16:creationId xmlns:a16="http://schemas.microsoft.com/office/drawing/2014/main" id="{B8862218-35EA-4D85-925C-435A76D7C45C}"/>
               </a:ext>
             </a:extLst>
           </p:cNvPr>
@@ -4935,7 +4935,7 @@
           <p:cNvPr id="9" name="high-copy">
             <a:extLst xmlns:a="http://schemas.openxmlformats.org/drawingml/2006/main">
               <a:ext uri="{FF2B5EF4-FFF2-40B4-BE49-F238E27FC236}">
-                <a16:creationId xmlns:a16="http://schemas.microsoft.com/office/drawing/2014/main" id="{8357D232-99BF-4712-873D-B4839AF5300B}"/>
+                <a16:creationId xmlns:a16="http://schemas.microsoft.com/office/drawing/2014/main" id="{322B79CA-0CDF-474D-B255-BF07E34C21A9}"/>
               </a:ext>
             </a:extLst>
           </p:cNvPr>
@@ -5051,7 +5051,7 @@
           <p:cNvPr id="10" name="low-group">
             <a:extLst xmlns:a="http://schemas.openxmlformats.org/drawingml/2006/main">
               <a:ext uri="{FF2B5EF4-FFF2-40B4-BE49-F238E27FC236}">
-                <a16:creationId xmlns:a16="http://schemas.microsoft.com/office/drawing/2014/main" id="{DC831539-3EBA-4897-A289-800635291C58}"/>
+                <a16:creationId xmlns:a16="http://schemas.microsoft.com/office/drawing/2014/main" id="{500E722E-CE13-40FD-887A-B991E81DC775}"/>
               </a:ext>
             </a:extLst>
           </p:cNvPr>
@@ -5086,7 +5086,7 @@
           <p:cNvPr id="11" name="low-title">
             <a:extLst xmlns:a="http://schemas.openxmlformats.org/drawingml/2006/main">
               <a:ext uri="{FF2B5EF4-FFF2-40B4-BE49-F238E27FC236}">
-                <a16:creationId xmlns:a16="http://schemas.microsoft.com/office/drawing/2014/main" id="{FCEA6D47-B456-416D-95A4-DE47143FC13E}"/>
+                <a16:creationId xmlns:a16="http://schemas.microsoft.com/office/drawing/2014/main" id="{13B2C01F-729E-443E-A9FC-970AD9CA7B7D}"/>
               </a:ext>
             </a:extLst>
           </p:cNvPr>
@@ -5148,7 +5148,7 @@
           <p:cNvPr id="12" name="low-copy">
             <a:extLst xmlns:a="http://schemas.openxmlformats.org/drawingml/2006/main">
               <a:ext uri="{FF2B5EF4-FFF2-40B4-BE49-F238E27FC236}">
-                <a16:creationId xmlns:a16="http://schemas.microsoft.com/office/drawing/2014/main" id="{073E348D-2B6A-4D34-A3ED-228961813094}"/>
+                <a16:creationId xmlns:a16="http://schemas.microsoft.com/office/drawing/2014/main" id="{070658E5-038E-45D5-AD50-19273C6A86D0}"/>
               </a:ext>
             </a:extLst>
           </p:cNvPr>
@@ -5264,7 +5264,7 @@
           <p:cNvPr id="13" name="pivot">
             <a:extLst xmlns:a="http://schemas.openxmlformats.org/drawingml/2006/main">
               <a:ext uri="{FF2B5EF4-FFF2-40B4-BE49-F238E27FC236}">
-                <a16:creationId xmlns:a16="http://schemas.microsoft.com/office/drawing/2014/main" id="{08ABE518-A740-421B-930B-F5E30DD892DB}"/>
+                <a16:creationId xmlns:a16="http://schemas.microsoft.com/office/drawing/2014/main" id="{CE10B13C-D50F-4DED-A828-D8590E26370C}"/>
               </a:ext>
             </a:extLst>
           </p:cNvPr>
@@ -5297,7 +5297,7 @@
           <p:cNvPr id="14" name="pivot-title">
             <a:extLst xmlns:a="http://schemas.openxmlformats.org/drawingml/2006/main">
               <a:ext uri="{FF2B5EF4-FFF2-40B4-BE49-F238E27FC236}">
-                <a16:creationId xmlns:a16="http://schemas.microsoft.com/office/drawing/2014/main" id="{6D33B40C-C407-4345-A8DC-C68FEEF27127}"/>
+                <a16:creationId xmlns:a16="http://schemas.microsoft.com/office/drawing/2014/main" id="{8453D9A6-E806-43C3-B42D-01B6686BAED0}"/>
               </a:ext>
             </a:extLst>
           </p:cNvPr>
@@ -5359,7 +5359,7 @@
           <p:cNvPr id="15" name="pivot-copy">
             <a:extLst xmlns:a="http://schemas.openxmlformats.org/drawingml/2006/main">
               <a:ext uri="{FF2B5EF4-FFF2-40B4-BE49-F238E27FC236}">
-                <a16:creationId xmlns:a16="http://schemas.microsoft.com/office/drawing/2014/main" id="{C80077FD-5DD1-4E1E-BA54-0719E1D9F2B0}"/>
+                <a16:creationId xmlns:a16="http://schemas.microsoft.com/office/drawing/2014/main" id="{BFDFAC71-DEBB-49A8-B0D1-31B7E577D48C}"/>
               </a:ext>
             </a:extLst>
           </p:cNvPr>
@@ -5527,7 +5527,7 @@
           <p:cNvPr id="18" name="bottom-note">
             <a:extLst xmlns:a="http://schemas.openxmlformats.org/drawingml/2006/main">
               <a:ext uri="{FF2B5EF4-FFF2-40B4-BE49-F238E27FC236}">
-                <a16:creationId xmlns:a16="http://schemas.microsoft.com/office/drawing/2014/main" id="{11B1DFE0-5967-4F8E-9954-A36FB1FE6D0A}"/>
+                <a16:creationId xmlns:a16="http://schemas.microsoft.com/office/drawing/2014/main" id="{DFDCC1FA-F7FD-4C81-A81C-86E40055E252}"/>
               </a:ext>
             </a:extLst>
           </p:cNvPr>
@@ -5587,7 +5587,7 @@
     </p:spTree>
     <p:extLst>
       <p:ext uri="{BB962C8B-B14F-4D97-AF65-F5344CB8AC3E}">
-        <p14:creationId xmlns:p14="http://schemas.microsoft.com/office/powerpoint/2010/main" val="2102540796"/>
+        <p14:creationId xmlns:p14="http://schemas.microsoft.com/office/powerpoint/2010/main" val="899497233"/>
       </p:ext>
     </p:extLst>
   </p:cSld>
@@ -5618,7 +5618,7 @@
           <p:cNvPr id="33" name="kicker">
             <a:extLst xmlns:a="http://schemas.openxmlformats.org/drawingml/2006/main">
               <a:ext uri="{FF2B5EF4-FFF2-40B4-BE49-F238E27FC236}">
-                <a16:creationId xmlns:a16="http://schemas.microsoft.com/office/drawing/2014/main" id="{C0C684A5-B81E-4D99-A66C-296F50CA6362}"/>
+                <a16:creationId xmlns:a16="http://schemas.microsoft.com/office/drawing/2014/main" id="{281F9D46-E52D-4C40-994B-014C5D6619C7}"/>
               </a:ext>
             </a:extLst>
           </p:cNvPr>
@@ -5680,7 +5680,7 @@
           <p:cNvPr id="2" name="title">
             <a:extLst xmlns:a="http://schemas.openxmlformats.org/drawingml/2006/main">
               <a:ext uri="{FF2B5EF4-FFF2-40B4-BE49-F238E27FC236}">
-                <a16:creationId xmlns:a16="http://schemas.microsoft.com/office/drawing/2014/main" id="{D6E5D192-5770-40AF-A680-DBFF9BB20AB4}"/>
+                <a16:creationId xmlns:a16="http://schemas.microsoft.com/office/drawing/2014/main" id="{29F1D3FF-22E9-4F47-B160-43D89658C0A7}"/>
               </a:ext>
             </a:extLst>
           </p:cNvPr>
@@ -5742,7 +5742,7 @@
           <p:cNvPr id="3" name="title-rule">
             <a:extLst xmlns:a="http://schemas.openxmlformats.org/drawingml/2006/main">
               <a:ext uri="{FF2B5EF4-FFF2-40B4-BE49-F238E27FC236}">
-                <a16:creationId xmlns:a16="http://schemas.microsoft.com/office/drawing/2014/main" id="{9FB6AF62-A1C7-465A-8C6E-C353E5ED449B}"/>
+                <a16:creationId xmlns:a16="http://schemas.microsoft.com/office/drawing/2014/main" id="{C0B068AE-E845-496F-81C0-F71E65CA8DD2}"/>
               </a:ext>
             </a:extLst>
           </p:cNvPr>
@@ -5775,7 +5775,7 @@
           <p:cNvPr id="4" name="footer-source">
             <a:extLst xmlns:a="http://schemas.openxmlformats.org/drawingml/2006/main">
               <a:ext uri="{FF2B5EF4-FFF2-40B4-BE49-F238E27FC236}">
-                <a16:creationId xmlns:a16="http://schemas.microsoft.com/office/drawing/2014/main" id="{AEE8511E-E11B-4344-BAE2-EF4DA9250361}"/>
+                <a16:creationId xmlns:a16="http://schemas.microsoft.com/office/drawing/2014/main" id="{04010EF9-3D78-4925-B8A0-1FF6355C025F}"/>
               </a:ext>
             </a:extLst>
           </p:cNvPr>
@@ -5837,7 +5837,7 @@
           <p:cNvPr id="5" name="footer-page">
             <a:extLst xmlns:a="http://schemas.openxmlformats.org/drawingml/2006/main">
               <a:ext uri="{FF2B5EF4-FFF2-40B4-BE49-F238E27FC236}">
-                <a16:creationId xmlns:a16="http://schemas.microsoft.com/office/drawing/2014/main" id="{22E3201A-2C10-455F-B328-7163D73A50DF}"/>
+                <a16:creationId xmlns:a16="http://schemas.microsoft.com/office/drawing/2014/main" id="{ECA598FA-EA8D-4DE6-B138-875D64000A9E}"/>
               </a:ext>
             </a:extLst>
           </p:cNvPr>
@@ -5899,7 +5899,7 @@
           <p:cNvPr id="6" name="lead">
             <a:extLst xmlns:a="http://schemas.openxmlformats.org/drawingml/2006/main">
               <a:ext uri="{FF2B5EF4-FFF2-40B4-BE49-F238E27FC236}">
-                <a16:creationId xmlns:a16="http://schemas.microsoft.com/office/drawing/2014/main" id="{04E3E325-0DBE-4D7D-8DD8-D306B341D9BA}"/>
+                <a16:creationId xmlns:a16="http://schemas.microsoft.com/office/drawing/2014/main" id="{81F53BA9-A337-4920-A591-2F3215C007EE}"/>
               </a:ext>
             </a:extLst>
           </p:cNvPr>
@@ -5961,7 +5961,7 @@
           <p:cNvPr id="7" name="six-container">
             <a:extLst xmlns:a="http://schemas.openxmlformats.org/drawingml/2006/main">
               <a:ext uri="{FF2B5EF4-FFF2-40B4-BE49-F238E27FC236}">
-                <a16:creationId xmlns:a16="http://schemas.microsoft.com/office/drawing/2014/main" id="{71953D58-84CA-40C0-B850-D7B2AF50C72B}"/>
+                <a16:creationId xmlns:a16="http://schemas.microsoft.com/office/drawing/2014/main" id="{8FC3BBC3-CB1A-4245-99F9-22F71129B843}"/>
               </a:ext>
             </a:extLst>
           </p:cNvPr>
@@ -5996,7 +5996,7 @@
           <p:cNvPr id="8" name="six-title">
             <a:extLst xmlns:a="http://schemas.openxmlformats.org/drawingml/2006/main">
               <a:ext uri="{FF2B5EF4-FFF2-40B4-BE49-F238E27FC236}">
-                <a16:creationId xmlns:a16="http://schemas.microsoft.com/office/drawing/2014/main" id="{0B8747BD-0972-4339-BCBA-BE7314199E79}"/>
+                <a16:creationId xmlns:a16="http://schemas.microsoft.com/office/drawing/2014/main" id="{8892EFC8-A759-4464-88B3-357F11CAF518}"/>
               </a:ext>
             </a:extLst>
           </p:cNvPr>
@@ -6058,7 +6058,7 @@
           <p:cNvPr id="9" name="six-0">
             <a:extLst xmlns:a="http://schemas.openxmlformats.org/drawingml/2006/main">
               <a:ext uri="{FF2B5EF4-FFF2-40B4-BE49-F238E27FC236}">
-                <a16:creationId xmlns:a16="http://schemas.microsoft.com/office/drawing/2014/main" id="{14DE922B-DD23-4B19-9C49-B5ED96E0286A}"/>
+                <a16:creationId xmlns:a16="http://schemas.microsoft.com/office/drawing/2014/main" id="{4205820D-6FEC-4E90-BE9C-C46CC75A70DA}"/>
               </a:ext>
             </a:extLst>
           </p:cNvPr>
@@ -6093,7 +6093,7 @@
           <p:cNvPr id="10" name="six-0a">
             <a:extLst xmlns:a="http://schemas.openxmlformats.org/drawingml/2006/main">
               <a:ext uri="{FF2B5EF4-FFF2-40B4-BE49-F238E27FC236}">
-                <a16:creationId xmlns:a16="http://schemas.microsoft.com/office/drawing/2014/main" id="{24B71D6E-DD6B-4912-BD17-5BB90E21C718}"/>
+                <a16:creationId xmlns:a16="http://schemas.microsoft.com/office/drawing/2014/main" id="{CBEE82C0-7A52-455F-A4A5-D928DCEF6404}"/>
               </a:ext>
             </a:extLst>
           </p:cNvPr>
@@ -6155,7 +6155,7 @@
           <p:cNvPr id="11" name="six-0b">
             <a:extLst xmlns:a="http://schemas.openxmlformats.org/drawingml/2006/main">
               <a:ext uri="{FF2B5EF4-FFF2-40B4-BE49-F238E27FC236}">
-                <a16:creationId xmlns:a16="http://schemas.microsoft.com/office/drawing/2014/main" id="{5981CC6A-9E8B-4FB6-9122-453BCF4970D6}"/>
+                <a16:creationId xmlns:a16="http://schemas.microsoft.com/office/drawing/2014/main" id="{60978777-C9D2-4EBE-9DFF-9150DF1BF6EA}"/>
               </a:ext>
             </a:extLst>
           </p:cNvPr>
@@ -6217,7 +6217,7 @@
           <p:cNvPr id="12" name="six-1">
             <a:extLst xmlns:a="http://schemas.openxmlformats.org/drawingml/2006/main">
               <a:ext uri="{FF2B5EF4-FFF2-40B4-BE49-F238E27FC236}">
-                <a16:creationId xmlns:a16="http://schemas.microsoft.com/office/drawing/2014/main" id="{3B5F0856-2053-410D-AD06-3E70CDEB46BB}"/>
+                <a16:creationId xmlns:a16="http://schemas.microsoft.com/office/drawing/2014/main" id="{4C3B7D7C-A35C-4E7A-B62A-F160C0A74610}"/>
               </a:ext>
             </a:extLst>
           </p:cNvPr>
@@ -6252,7 +6252,7 @@
           <p:cNvPr id="13" name="six-1a">
             <a:extLst xmlns:a="http://schemas.openxmlformats.org/drawingml/2006/main">
               <a:ext uri="{FF2B5EF4-FFF2-40B4-BE49-F238E27FC236}">
-                <a16:creationId xmlns:a16="http://schemas.microsoft.com/office/drawing/2014/main" id="{C148F746-69D1-4409-97EC-2407682AAE44}"/>
+                <a16:creationId xmlns:a16="http://schemas.microsoft.com/office/drawing/2014/main" id="{7AD6751A-A11D-4072-B6BF-F759BBF109C6}"/>
               </a:ext>
             </a:extLst>
           </p:cNvPr>
@@ -6314,7 +6314,7 @@
           <p:cNvPr id="14" name="six-1b">
             <a:extLst xmlns:a="http://schemas.openxmlformats.org/drawingml/2006/main">
               <a:ext uri="{FF2B5EF4-FFF2-40B4-BE49-F238E27FC236}">
-                <a16:creationId xmlns:a16="http://schemas.microsoft.com/office/drawing/2014/main" id="{4BC5725C-3F9F-46C5-ADAD-34A076E2AA56}"/>
+                <a16:creationId xmlns:a16="http://schemas.microsoft.com/office/drawing/2014/main" id="{D862132F-B159-40F0-BD15-C1D57735E5AB}"/>
               </a:ext>
             </a:extLst>
           </p:cNvPr>
@@ -6376,7 +6376,7 @@
           <p:cNvPr id="15" name="six-2">
             <a:extLst xmlns:a="http://schemas.openxmlformats.org/drawingml/2006/main">
               <a:ext uri="{FF2B5EF4-FFF2-40B4-BE49-F238E27FC236}">
-                <a16:creationId xmlns:a16="http://schemas.microsoft.com/office/drawing/2014/main" id="{D42C6600-238A-406A-9DC1-6A219296C017}"/>
+                <a16:creationId xmlns:a16="http://schemas.microsoft.com/office/drawing/2014/main" id="{D9C22F0B-09AC-42AC-A7C0-B17B48F007AD}"/>
               </a:ext>
             </a:extLst>
           </p:cNvPr>
@@ -6411,7 +6411,7 @@
           <p:cNvPr id="16" name="six-2a">
             <a:extLst xmlns:a="http://schemas.openxmlformats.org/drawingml/2006/main">
               <a:ext uri="{FF2B5EF4-FFF2-40B4-BE49-F238E27FC236}">
-                <a16:creationId xmlns:a16="http://schemas.microsoft.com/office/drawing/2014/main" id="{1C569912-B136-45C1-A56A-F461DE5BF59F}"/>
+                <a16:creationId xmlns:a16="http://schemas.microsoft.com/office/drawing/2014/main" id="{FB40B2DA-513B-40D8-B038-CBC6721928E0}"/>
               </a:ext>
             </a:extLst>
           </p:cNvPr>
@@ -6473,7 +6473,7 @@
           <p:cNvPr id="17" name="six-2b">
             <a:extLst xmlns:a="http://schemas.openxmlformats.org/drawingml/2006/main">
               <a:ext uri="{FF2B5EF4-FFF2-40B4-BE49-F238E27FC236}">
-                <a16:creationId xmlns:a16="http://schemas.microsoft.com/office/drawing/2014/main" id="{9E59661A-D956-48A1-9555-77839DC5F110}"/>
+                <a16:creationId xmlns:a16="http://schemas.microsoft.com/office/drawing/2014/main" id="{824CCBA0-223C-4D38-9368-7AD431C1F2BE}"/>
               </a:ext>
             </a:extLst>
           </p:cNvPr>
@@ -6535,7 +6535,7 @@
           <p:cNvPr id="18" name="six-3">
             <a:extLst xmlns:a="http://schemas.openxmlformats.org/drawingml/2006/main">
               <a:ext uri="{FF2B5EF4-FFF2-40B4-BE49-F238E27FC236}">
-                <a16:creationId xmlns:a16="http://schemas.microsoft.com/office/drawing/2014/main" id="{0584D5C2-72CA-4C1C-B205-F4DD366D2E41}"/>
+                <a16:creationId xmlns:a16="http://schemas.microsoft.com/office/drawing/2014/main" id="{13288D44-22DF-4C61-8F65-E840CF6609EB}"/>
               </a:ext>
             </a:extLst>
           </p:cNvPr>
@@ -6570,7 +6570,7 @@
           <p:cNvPr id="19" name="six-3a">
             <a:extLst xmlns:a="http://schemas.openxmlformats.org/drawingml/2006/main">
               <a:ext uri="{FF2B5EF4-FFF2-40B4-BE49-F238E27FC236}">
-                <a16:creationId xmlns:a16="http://schemas.microsoft.com/office/drawing/2014/main" id="{BF351CC2-F4BF-4F9A-BE20-E4A87A9C8055}"/>
+                <a16:creationId xmlns:a16="http://schemas.microsoft.com/office/drawing/2014/main" id="{3F457B1E-0825-4A9B-8DEA-F07799E5DA90}"/>
               </a:ext>
             </a:extLst>
           </p:cNvPr>
@@ -6632,7 +6632,7 @@
           <p:cNvPr id="20" name="six-3b">
             <a:extLst xmlns:a="http://schemas.openxmlformats.org/drawingml/2006/main">
               <a:ext uri="{FF2B5EF4-FFF2-40B4-BE49-F238E27FC236}">
-                <a16:creationId xmlns:a16="http://schemas.microsoft.com/office/drawing/2014/main" id="{5BD950D5-F8BB-4D3E-996C-3E6586295BA6}"/>
+                <a16:creationId xmlns:a16="http://schemas.microsoft.com/office/drawing/2014/main" id="{CB1F8D67-3518-4ADD-9987-92AAB7AE7B45}"/>
               </a:ext>
             </a:extLst>
           </p:cNvPr>
@@ -6694,7 +6694,7 @@
           <p:cNvPr id="21" name="six-4">
             <a:extLst xmlns:a="http://schemas.openxmlformats.org/drawingml/2006/main">
               <a:ext uri="{FF2B5EF4-FFF2-40B4-BE49-F238E27FC236}">
-                <a16:creationId xmlns:a16="http://schemas.microsoft.com/office/drawing/2014/main" id="{3C667D4E-5FF4-41F2-89B2-565123828BC7}"/>
+                <a16:creationId xmlns:a16="http://schemas.microsoft.com/office/drawing/2014/main" id="{58AA2BC3-6458-44E9-A7BE-B31876498F22}"/>
               </a:ext>
             </a:extLst>
           </p:cNvPr>
@@ -6729,7 +6729,7 @@
           <p:cNvPr id="22" name="six-4a">
             <a:extLst xmlns:a="http://schemas.openxmlformats.org/drawingml/2006/main">
               <a:ext uri="{FF2B5EF4-FFF2-40B4-BE49-F238E27FC236}">
-                <a16:creationId xmlns:a16="http://schemas.microsoft.com/office/drawing/2014/main" id="{4070167F-DC74-417C-91CD-FD6958E1609D}"/>
+                <a16:creationId xmlns:a16="http://schemas.microsoft.com/office/drawing/2014/main" id="{27C98543-B173-4A6C-9C83-8F1822702922}"/>
               </a:ext>
             </a:extLst>
           </p:cNvPr>
@@ -6791,7 +6791,7 @@
           <p:cNvPr id="23" name="six-4b">
             <a:extLst xmlns:a="http://schemas.openxmlformats.org/drawingml/2006/main">
               <a:ext uri="{FF2B5EF4-FFF2-40B4-BE49-F238E27FC236}">
-                <a16:creationId xmlns:a16="http://schemas.microsoft.com/office/drawing/2014/main" id="{BC1B7D8D-7DF8-40BC-A905-DBDB9F2704FC}"/>
+                <a16:creationId xmlns:a16="http://schemas.microsoft.com/office/drawing/2014/main" id="{0033CC9A-5040-426A-BCE3-D9E3BA787521}"/>
               </a:ext>
             </a:extLst>
           </p:cNvPr>
@@ -6853,7 +6853,7 @@
           <p:cNvPr id="24" name="six-5">
             <a:extLst xmlns:a="http://schemas.openxmlformats.org/drawingml/2006/main">
               <a:ext uri="{FF2B5EF4-FFF2-40B4-BE49-F238E27FC236}">
-                <a16:creationId xmlns:a16="http://schemas.microsoft.com/office/drawing/2014/main" id="{160E11B7-E28C-4E73-B354-50465DE83F5F}"/>
+                <a16:creationId xmlns:a16="http://schemas.microsoft.com/office/drawing/2014/main" id="{F5DA9991-E9CD-400E-9597-116EDC9C164B}"/>
               </a:ext>
             </a:extLst>
           </p:cNvPr>
@@ -6888,7 +6888,7 @@
           <p:cNvPr id="25" name="six-5a">
             <a:extLst xmlns:a="http://schemas.openxmlformats.org/drawingml/2006/main">
               <a:ext uri="{FF2B5EF4-FFF2-40B4-BE49-F238E27FC236}">
-                <a16:creationId xmlns:a16="http://schemas.microsoft.com/office/drawing/2014/main" id="{C103B203-8C52-4763-8700-3559C985DFD3}"/>
+                <a16:creationId xmlns:a16="http://schemas.microsoft.com/office/drawing/2014/main" id="{537C5708-8158-43C5-85DF-BBE47856699B}"/>
               </a:ext>
             </a:extLst>
           </p:cNvPr>
@@ -6950,7 +6950,7 @@
           <p:cNvPr id="26" name="six-5b">
             <a:extLst xmlns:a="http://schemas.openxmlformats.org/drawingml/2006/main">
               <a:ext uri="{FF2B5EF4-FFF2-40B4-BE49-F238E27FC236}">
-                <a16:creationId xmlns:a16="http://schemas.microsoft.com/office/drawing/2014/main" id="{4A428976-7274-4287-9D39-E8041D943020}"/>
+                <a16:creationId xmlns:a16="http://schemas.microsoft.com/office/drawing/2014/main" id="{BE38DC13-46EF-403D-B428-78EA9F44E81B}"/>
               </a:ext>
             </a:extLst>
           </p:cNvPr>
@@ -7012,7 +7012,7 @@
           <p:cNvPr id="27" name="young-site">
             <a:extLst xmlns:a="http://schemas.openxmlformats.org/drawingml/2006/main">
               <a:ext uri="{FF2B5EF4-FFF2-40B4-BE49-F238E27FC236}">
-                <a16:creationId xmlns:a16="http://schemas.microsoft.com/office/drawing/2014/main" id="{C9980EAB-19E7-4A4B-84B8-9BA9866C5352}"/>
+                <a16:creationId xmlns:a16="http://schemas.microsoft.com/office/drawing/2014/main" id="{6F53BAD6-E980-449E-84DB-661787BF5135}"/>
               </a:ext>
             </a:extLst>
           </p:cNvPr>
@@ -7045,7 +7045,7 @@
           <p:cNvPr id="28" name="site-title">
             <a:extLst xmlns:a="http://schemas.openxmlformats.org/drawingml/2006/main">
               <a:ext uri="{FF2B5EF4-FFF2-40B4-BE49-F238E27FC236}">
-                <a16:creationId xmlns:a16="http://schemas.microsoft.com/office/drawing/2014/main" id="{D7D86BA9-E6FB-42A7-B4C6-DA355785EC95}"/>
+                <a16:creationId xmlns:a16="http://schemas.microsoft.com/office/drawing/2014/main" id="{19158260-2FF6-4662-9BD6-4181555F462F}"/>
               </a:ext>
             </a:extLst>
           </p:cNvPr>
@@ -7107,7 +7107,7 @@
           <p:cNvPr id="29" name="site-copy">
             <a:extLst xmlns:a="http://schemas.openxmlformats.org/drawingml/2006/main">
               <a:ext uri="{FF2B5EF4-FFF2-40B4-BE49-F238E27FC236}">
-                <a16:creationId xmlns:a16="http://schemas.microsoft.com/office/drawing/2014/main" id="{52FD051D-D2BC-4411-ADDC-5E03F25C618F}"/>
+                <a16:creationId xmlns:a16="http://schemas.microsoft.com/office/drawing/2014/main" id="{4EE93A8A-018A-4455-BEDD-CBAAF5F922A3}"/>
               </a:ext>
             </a:extLst>
           </p:cNvPr>
@@ -7223,7 +7223,7 @@
           <p:cNvPr id="30" name="anchor">
             <a:extLst xmlns:a="http://schemas.openxmlformats.org/drawingml/2006/main">
               <a:ext uri="{FF2B5EF4-FFF2-40B4-BE49-F238E27FC236}">
-                <a16:creationId xmlns:a16="http://schemas.microsoft.com/office/drawing/2014/main" id="{5C28A770-B535-456F-8226-A42C4CD84B8E}"/>
+                <a16:creationId xmlns:a16="http://schemas.microsoft.com/office/drawing/2014/main" id="{4E03E5C3-6A92-4714-8DDF-486B7B9CB46D}"/>
               </a:ext>
             </a:extLst>
           </p:cNvPr>
@@ -7278,7 +7278,7 @@
           <p:cNvPr id="32" name="bottom-note">
             <a:extLst xmlns:a="http://schemas.openxmlformats.org/drawingml/2006/main">
               <a:ext uri="{FF2B5EF4-FFF2-40B4-BE49-F238E27FC236}">
-                <a16:creationId xmlns:a16="http://schemas.microsoft.com/office/drawing/2014/main" id="{C59F3FF6-426C-474E-8571-EB3BF28A4BD8}"/>
+                <a16:creationId xmlns:a16="http://schemas.microsoft.com/office/drawing/2014/main" id="{48ACAD7F-505F-43DC-BC7A-40BAB3B92376}"/>
               </a:ext>
             </a:extLst>
           </p:cNvPr>
@@ -7338,7 +7338,7 @@
     </p:spTree>
     <p:extLst>
       <p:ext uri="{BB962C8B-B14F-4D97-AF65-F5344CB8AC3E}">
-        <p14:creationId xmlns:p14="http://schemas.microsoft.com/office/powerpoint/2010/main" val="1144524019"/>
+        <p14:creationId xmlns:p14="http://schemas.microsoft.com/office/powerpoint/2010/main" val="1657432709"/>
       </p:ext>
     </p:extLst>
   </p:cSld>
@@ -7369,7 +7369,7 @@
           <p:cNvPr id="23" name="kicker">
             <a:extLst xmlns:a="http://schemas.openxmlformats.org/drawingml/2006/main">
               <a:ext uri="{FF2B5EF4-FFF2-40B4-BE49-F238E27FC236}">
-                <a16:creationId xmlns:a16="http://schemas.microsoft.com/office/drawing/2014/main" id="{B31BAFE8-089D-4BA3-85DC-6AAE66970760}"/>
+                <a16:creationId xmlns:a16="http://schemas.microsoft.com/office/drawing/2014/main" id="{666593F8-8DEF-4A52-9AF2-B32347F8885E}"/>
               </a:ext>
             </a:extLst>
           </p:cNvPr>
@@ -7431,7 +7431,7 @@
           <p:cNvPr id="2" name="title">
             <a:extLst xmlns:a="http://schemas.openxmlformats.org/drawingml/2006/main">
               <a:ext uri="{FF2B5EF4-FFF2-40B4-BE49-F238E27FC236}">
-                <a16:creationId xmlns:a16="http://schemas.microsoft.com/office/drawing/2014/main" id="{B03537CF-390F-430D-AAB3-294C203EAA7D}"/>
+                <a16:creationId xmlns:a16="http://schemas.microsoft.com/office/drawing/2014/main" id="{4B0014F2-BFD4-4D11-8C45-136786E2AB1C}"/>
               </a:ext>
             </a:extLst>
           </p:cNvPr>
@@ -7493,7 +7493,7 @@
           <p:cNvPr id="3" name="title-rule">
             <a:extLst xmlns:a="http://schemas.openxmlformats.org/drawingml/2006/main">
               <a:ext uri="{FF2B5EF4-FFF2-40B4-BE49-F238E27FC236}">
-                <a16:creationId xmlns:a16="http://schemas.microsoft.com/office/drawing/2014/main" id="{27D35D34-6D60-464D-BC28-11646D6DDC2B}"/>
+                <a16:creationId xmlns:a16="http://schemas.microsoft.com/office/drawing/2014/main" id="{66BB75B2-4651-4500-A85F-3D9B919F4A9E}"/>
               </a:ext>
             </a:extLst>
           </p:cNvPr>
@@ -7526,7 +7526,7 @@
           <p:cNvPr id="4" name="footer-source">
             <a:extLst xmlns:a="http://schemas.openxmlformats.org/drawingml/2006/main">
               <a:ext uri="{FF2B5EF4-FFF2-40B4-BE49-F238E27FC236}">
-                <a16:creationId xmlns:a16="http://schemas.microsoft.com/office/drawing/2014/main" id="{45471FF1-E6A5-40FA-9E2A-EA0DE14134B2}"/>
+                <a16:creationId xmlns:a16="http://schemas.microsoft.com/office/drawing/2014/main" id="{2676DE9F-022D-496C-9C73-A89F1FEB65F8}"/>
               </a:ext>
             </a:extLst>
           </p:cNvPr>
@@ -7588,7 +7588,7 @@
           <p:cNvPr id="5" name="footer-page">
             <a:extLst xmlns:a="http://schemas.openxmlformats.org/drawingml/2006/main">
               <a:ext uri="{FF2B5EF4-FFF2-40B4-BE49-F238E27FC236}">
-                <a16:creationId xmlns:a16="http://schemas.microsoft.com/office/drawing/2014/main" id="{366EDBA8-B7D0-4F31-AE31-26CD90FAEF4B}"/>
+                <a16:creationId xmlns:a16="http://schemas.microsoft.com/office/drawing/2014/main" id="{94CE3EEF-C00F-4315-BE86-C93B0E6B07C7}"/>
               </a:ext>
             </a:extLst>
           </p:cNvPr>
@@ -7650,7 +7650,7 @@
           <p:cNvPr id="6" name="lead">
             <a:extLst xmlns:a="http://schemas.openxmlformats.org/drawingml/2006/main">
               <a:ext uri="{FF2B5EF4-FFF2-40B4-BE49-F238E27FC236}">
-                <a16:creationId xmlns:a16="http://schemas.microsoft.com/office/drawing/2014/main" id="{1CA98A27-79F2-40DF-99CE-6A29737007CB}"/>
+                <a16:creationId xmlns:a16="http://schemas.microsoft.com/office/drawing/2014/main" id="{A426C976-D9DF-46EE-A271-9EEB9D5C8715}"/>
               </a:ext>
             </a:extLst>
           </p:cNvPr>
@@ -7712,7 +7712,7 @@
           <p:cNvPr id="7" name="matrix-center">
             <a:extLst xmlns:a="http://schemas.openxmlformats.org/drawingml/2006/main">
               <a:ext uri="{FF2B5EF4-FFF2-40B4-BE49-F238E27FC236}">
-                <a16:creationId xmlns:a16="http://schemas.microsoft.com/office/drawing/2014/main" id="{CB613D55-F530-4D5D-9BE7-589D6D671810}"/>
+                <a16:creationId xmlns:a16="http://schemas.microsoft.com/office/drawing/2014/main" id="{E1D122D9-FC59-4B66-8320-B1299BBDD054}"/>
               </a:ext>
             </a:extLst>
           </p:cNvPr>
@@ -7745,7 +7745,7 @@
           <p:cNvPr id="8" name="matrix-big">
             <a:extLst xmlns:a="http://schemas.openxmlformats.org/drawingml/2006/main">
               <a:ext uri="{FF2B5EF4-FFF2-40B4-BE49-F238E27FC236}">
-                <a16:creationId xmlns:a16="http://schemas.microsoft.com/office/drawing/2014/main" id="{0090AB5C-7D21-4D3F-BC28-B8256E4A8BB5}"/>
+                <a16:creationId xmlns:a16="http://schemas.microsoft.com/office/drawing/2014/main" id="{EF83814F-2401-4F1A-8266-E243EE4E32F8}"/>
               </a:ext>
             </a:extLst>
           </p:cNvPr>
@@ -7807,7 +7807,7 @@
           <p:cNvPr id="9" name="matrix-small">
             <a:extLst xmlns:a="http://schemas.openxmlformats.org/drawingml/2006/main">
               <a:ext uri="{FF2B5EF4-FFF2-40B4-BE49-F238E27FC236}">
-                <a16:creationId xmlns:a16="http://schemas.microsoft.com/office/drawing/2014/main" id="{900FC751-E1B7-492C-98D9-C52D42006C3E}"/>
+                <a16:creationId xmlns:a16="http://schemas.microsoft.com/office/drawing/2014/main" id="{7CFEDB39-B0AB-425F-96B4-4680F5F0AB81}"/>
               </a:ext>
             </a:extLst>
           </p:cNvPr>
@@ -7869,7 +7869,7 @@
           <p:cNvPr id="10" name="matrix-chain">
             <a:extLst xmlns:a="http://schemas.openxmlformats.org/drawingml/2006/main">
               <a:ext uri="{FF2B5EF4-FFF2-40B4-BE49-F238E27FC236}">
-                <a16:creationId xmlns:a16="http://schemas.microsoft.com/office/drawing/2014/main" id="{DBE30977-5B55-4BDF-9EA3-588A461C37B8}"/>
+                <a16:creationId xmlns:a16="http://schemas.microsoft.com/office/drawing/2014/main" id="{F86730EB-7837-42DC-A34A-301C00B372E5}"/>
               </a:ext>
             </a:extLst>
           </p:cNvPr>
@@ -7904,7 +7904,7 @@
           <p:cNvPr id="11" name="chain-title">
             <a:extLst xmlns:a="http://schemas.openxmlformats.org/drawingml/2006/main">
               <a:ext uri="{FF2B5EF4-FFF2-40B4-BE49-F238E27FC236}">
-                <a16:creationId xmlns:a16="http://schemas.microsoft.com/office/drawing/2014/main" id="{1B63F1CC-4824-413A-A376-A954B7B62CD3}"/>
+                <a16:creationId xmlns:a16="http://schemas.microsoft.com/office/drawing/2014/main" id="{D33CB91A-93A3-4857-BF0B-8396FB301196}"/>
               </a:ext>
             </a:extLst>
           </p:cNvPr>
@@ -7966,7 +7966,7 @@
           <p:cNvPr id="12" name="chain-copy">
             <a:extLst xmlns:a="http://schemas.openxmlformats.org/drawingml/2006/main">
               <a:ext uri="{FF2B5EF4-FFF2-40B4-BE49-F238E27FC236}">
-                <a16:creationId xmlns:a16="http://schemas.microsoft.com/office/drawing/2014/main" id="{B19F48B1-A60F-42CC-A58B-123940B5A069}"/>
+                <a16:creationId xmlns:a16="http://schemas.microsoft.com/office/drawing/2014/main" id="{2344588A-DFA0-4B74-8557-DC37E45FC9F4}"/>
               </a:ext>
             </a:extLst>
           </p:cNvPr>
@@ -8109,7 +8109,7 @@
           <p:cNvPr id="13" name="matrix-classes">
             <a:extLst xmlns:a="http://schemas.openxmlformats.org/drawingml/2006/main">
               <a:ext uri="{FF2B5EF4-FFF2-40B4-BE49-F238E27FC236}">
-                <a16:creationId xmlns:a16="http://schemas.microsoft.com/office/drawing/2014/main" id="{AB8B88D2-238D-4791-A89F-E5364727D984}"/>
+                <a16:creationId xmlns:a16="http://schemas.microsoft.com/office/drawing/2014/main" id="{59E376F8-3435-46A7-A80F-EA1BD478053F}"/>
               </a:ext>
             </a:extLst>
           </p:cNvPr>
@@ -8144,7 +8144,7 @@
           <p:cNvPr id="14" name="classes-title">
             <a:extLst xmlns:a="http://schemas.openxmlformats.org/drawingml/2006/main">
               <a:ext uri="{FF2B5EF4-FFF2-40B4-BE49-F238E27FC236}">
-                <a16:creationId xmlns:a16="http://schemas.microsoft.com/office/drawing/2014/main" id="{A0C23977-9973-46BF-B1C2-F0CCF3ABAE37}"/>
+                <a16:creationId xmlns:a16="http://schemas.microsoft.com/office/drawing/2014/main" id="{EC92B034-D06D-48E6-AEC7-469940871626}"/>
               </a:ext>
             </a:extLst>
           </p:cNvPr>
@@ -8206,7 +8206,7 @@
           <p:cNvPr id="15" name="classes-copy">
             <a:extLst xmlns:a="http://schemas.openxmlformats.org/drawingml/2006/main">
               <a:ext uri="{FF2B5EF4-FFF2-40B4-BE49-F238E27FC236}">
-                <a16:creationId xmlns:a16="http://schemas.microsoft.com/office/drawing/2014/main" id="{3CF46BA7-B0FB-49A7-97F5-F79D16DABB2D}"/>
+                <a16:creationId xmlns:a16="http://schemas.microsoft.com/office/drawing/2014/main" id="{7B1E8177-EA97-472D-8A15-E3A217650F34}"/>
               </a:ext>
             </a:extLst>
           </p:cNvPr>
@@ -8322,7 +8322,7 @@
           <p:cNvPr id="16" name="matrix-scenes">
             <a:extLst xmlns:a="http://schemas.openxmlformats.org/drawingml/2006/main">
               <a:ext uri="{FF2B5EF4-FFF2-40B4-BE49-F238E27FC236}">
-                <a16:creationId xmlns:a16="http://schemas.microsoft.com/office/drawing/2014/main" id="{4FBD1461-DCDE-4F1A-AA6F-C89CCDAA4F80}"/>
+                <a16:creationId xmlns:a16="http://schemas.microsoft.com/office/drawing/2014/main" id="{F02FC0B0-4953-4CF2-9610-9CAAFA23EEF1}"/>
               </a:ext>
             </a:extLst>
           </p:cNvPr>
@@ -8357,7 +8357,7 @@
           <p:cNvPr id="17" name="scenes-title">
             <a:extLst xmlns:a="http://schemas.openxmlformats.org/drawingml/2006/main">
               <a:ext uri="{FF2B5EF4-FFF2-40B4-BE49-F238E27FC236}">
-                <a16:creationId xmlns:a16="http://schemas.microsoft.com/office/drawing/2014/main" id="{73378EF3-D07C-4733-86A6-082FA28791F8}"/>
+                <a16:creationId xmlns:a16="http://schemas.microsoft.com/office/drawing/2014/main" id="{F79A7526-1C0E-4F2C-85BD-6FD85CD41640}"/>
               </a:ext>
             </a:extLst>
           </p:cNvPr>
@@ -8419,7 +8419,7 @@
           <p:cNvPr id="18" name="scenes-copy">
             <a:extLst xmlns:a="http://schemas.openxmlformats.org/drawingml/2006/main">
               <a:ext uri="{FF2B5EF4-FFF2-40B4-BE49-F238E27FC236}">
-                <a16:creationId xmlns:a16="http://schemas.microsoft.com/office/drawing/2014/main" id="{51DFD3D9-6F12-4ADB-874F-4A300AFDD5F4}"/>
+                <a16:creationId xmlns:a16="http://schemas.microsoft.com/office/drawing/2014/main" id="{819F0789-E43E-4BA5-B0A8-D3B36FD2956E}"/>
               </a:ext>
             </a:extLst>
           </p:cNvPr>
@@ -8559,7 +8559,7 @@
           <p:cNvPr id="22" name="bottom-note">
             <a:extLst xmlns:a="http://schemas.openxmlformats.org/drawingml/2006/main">
               <a:ext uri="{FF2B5EF4-FFF2-40B4-BE49-F238E27FC236}">
-                <a16:creationId xmlns:a16="http://schemas.microsoft.com/office/drawing/2014/main" id="{49B6F6AF-52EE-4376-B8F5-01C040E2F392}"/>
+                <a16:creationId xmlns:a16="http://schemas.microsoft.com/office/drawing/2014/main" id="{2870F645-19B9-44BF-853D-2E54C17E37B2}"/>
               </a:ext>
             </a:extLst>
           </p:cNvPr>
@@ -8619,7 +8619,7 @@
     </p:spTree>
     <p:extLst>
       <p:ext uri="{BB962C8B-B14F-4D97-AF65-F5344CB8AC3E}">
-        <p14:creationId xmlns:p14="http://schemas.microsoft.com/office/powerpoint/2010/main" val="458241092"/>
+        <p14:creationId xmlns:p14="http://schemas.microsoft.com/office/powerpoint/2010/main" val="1790834298"/>
       </p:ext>
     </p:extLst>
   </p:cSld>
@@ -8650,7 +8650,7 @@
           <p:cNvPr id="28" name="kicker">
             <a:extLst xmlns:a="http://schemas.openxmlformats.org/drawingml/2006/main">
               <a:ext uri="{FF2B5EF4-FFF2-40B4-BE49-F238E27FC236}">
-                <a16:creationId xmlns:a16="http://schemas.microsoft.com/office/drawing/2014/main" id="{88960267-84E2-498A-91FE-6C8D2C25C53E}"/>
+                <a16:creationId xmlns:a16="http://schemas.microsoft.com/office/drawing/2014/main" id="{BCE645D6-B04E-4F36-A36F-FABEE4D977CF}"/>
               </a:ext>
             </a:extLst>
           </p:cNvPr>
@@ -8712,7 +8712,7 @@
           <p:cNvPr id="2" name="title">
             <a:extLst xmlns:a="http://schemas.openxmlformats.org/drawingml/2006/main">
               <a:ext uri="{FF2B5EF4-FFF2-40B4-BE49-F238E27FC236}">
-                <a16:creationId xmlns:a16="http://schemas.microsoft.com/office/drawing/2014/main" id="{18ADA4F0-9F06-4444-8BEE-20708CE993C5}"/>
+                <a16:creationId xmlns:a16="http://schemas.microsoft.com/office/drawing/2014/main" id="{AFF67D3C-6B0D-4840-8F49-B6A43405CCB9}"/>
               </a:ext>
             </a:extLst>
           </p:cNvPr>
@@ -8774,7 +8774,7 @@
           <p:cNvPr id="3" name="title-rule">
             <a:extLst xmlns:a="http://schemas.openxmlformats.org/drawingml/2006/main">
               <a:ext uri="{FF2B5EF4-FFF2-40B4-BE49-F238E27FC236}">
-                <a16:creationId xmlns:a16="http://schemas.microsoft.com/office/drawing/2014/main" id="{A2AC0020-658B-4F28-A87F-6BA6738276B4}"/>
+                <a16:creationId xmlns:a16="http://schemas.microsoft.com/office/drawing/2014/main" id="{E7135A97-5A4D-4D4A-9128-7A6F4CCDEC0D}"/>
               </a:ext>
             </a:extLst>
           </p:cNvPr>
@@ -8807,7 +8807,7 @@
           <p:cNvPr id="4" name="footer-source">
             <a:extLst xmlns:a="http://schemas.openxmlformats.org/drawingml/2006/main">
               <a:ext uri="{FF2B5EF4-FFF2-40B4-BE49-F238E27FC236}">
-                <a16:creationId xmlns:a16="http://schemas.microsoft.com/office/drawing/2014/main" id="{4CEF6D79-4C5E-4420-8D18-02609BE7A243}"/>
+                <a16:creationId xmlns:a16="http://schemas.microsoft.com/office/drawing/2014/main" id="{157A6652-9F73-46A3-8D35-B96A40FFA830}"/>
               </a:ext>
             </a:extLst>
           </p:cNvPr>
@@ -8869,7 +8869,7 @@
           <p:cNvPr id="5" name="footer-page">
             <a:extLst xmlns:a="http://schemas.openxmlformats.org/drawingml/2006/main">
               <a:ext uri="{FF2B5EF4-FFF2-40B4-BE49-F238E27FC236}">
-                <a16:creationId xmlns:a16="http://schemas.microsoft.com/office/drawing/2014/main" id="{BE7C5B00-8020-4B43-AD9D-D7125E8F8C72}"/>
+                <a16:creationId xmlns:a16="http://schemas.microsoft.com/office/drawing/2014/main" id="{1DBDE8D3-91F9-4055-9B55-0EE6C63E2808}"/>
               </a:ext>
             </a:extLst>
           </p:cNvPr>
@@ -8931,7 +8931,7 @@
           <p:cNvPr id="6" name="lead">
             <a:extLst xmlns:a="http://schemas.openxmlformats.org/drawingml/2006/main">
               <a:ext uri="{FF2B5EF4-FFF2-40B4-BE49-F238E27FC236}">
-                <a16:creationId xmlns:a16="http://schemas.microsoft.com/office/drawing/2014/main" id="{B9E02F0C-30B0-461E-8756-E7457B398642}"/>
+                <a16:creationId xmlns:a16="http://schemas.microsoft.com/office/drawing/2014/main" id="{9CA90FA0-1D9E-4F85-B130-17DA578CB83A}"/>
               </a:ext>
             </a:extLst>
           </p:cNvPr>
@@ -8993,7 +8993,7 @@
           <p:cNvPr id="7" name="task-a">
             <a:extLst xmlns:a="http://schemas.openxmlformats.org/drawingml/2006/main">
               <a:ext uri="{FF2B5EF4-FFF2-40B4-BE49-F238E27FC236}">
-                <a16:creationId xmlns:a16="http://schemas.microsoft.com/office/drawing/2014/main" id="{E8BD6396-CAD4-408C-BC93-3FB1E2F45E6F}"/>
+                <a16:creationId xmlns:a16="http://schemas.microsoft.com/office/drawing/2014/main" id="{2187E430-CA0E-4B88-BF76-47D9D5A8308C}"/>
               </a:ext>
             </a:extLst>
           </p:cNvPr>
@@ -9028,7 +9028,7 @@
           <p:cNvPr id="8" name="task-b">
             <a:extLst xmlns:a="http://schemas.openxmlformats.org/drawingml/2006/main">
               <a:ext uri="{FF2B5EF4-FFF2-40B4-BE49-F238E27FC236}">
-                <a16:creationId xmlns:a16="http://schemas.microsoft.com/office/drawing/2014/main" id="{52F93203-0836-4E6D-B7DF-E07CF2764C4C}"/>
+                <a16:creationId xmlns:a16="http://schemas.microsoft.com/office/drawing/2014/main" id="{2766691C-2510-4688-9ADC-C6B871ECD86A}"/>
               </a:ext>
             </a:extLst>
           </p:cNvPr>
@@ -9063,7 +9063,7 @@
           <p:cNvPr id="9" name="task-c">
             <a:extLst xmlns:a="http://schemas.openxmlformats.org/drawingml/2006/main">
               <a:ext uri="{FF2B5EF4-FFF2-40B4-BE49-F238E27FC236}">
-                <a16:creationId xmlns:a16="http://schemas.microsoft.com/office/drawing/2014/main" id="{6A6ED2B5-D044-4C3F-9C58-FF5DE03A8136}"/>
+                <a16:creationId xmlns:a16="http://schemas.microsoft.com/office/drawing/2014/main" id="{C6D0D1FC-A419-4F17-B3F9-12E38D14F16A}"/>
               </a:ext>
             </a:extLst>
           </p:cNvPr>
@@ -9098,7 +9098,7 @@
           <p:cNvPr id="10" name="task-d">
             <a:extLst xmlns:a="http://schemas.openxmlformats.org/drawingml/2006/main">
               <a:ext uri="{FF2B5EF4-FFF2-40B4-BE49-F238E27FC236}">
-                <a16:creationId xmlns:a16="http://schemas.microsoft.com/office/drawing/2014/main" id="{8140B7E9-A321-443D-9FE4-F9A419CA0578}"/>
+                <a16:creationId xmlns:a16="http://schemas.microsoft.com/office/drawing/2014/main" id="{64CC9781-A6CC-4FB5-AB85-5BC964E3802F}"/>
               </a:ext>
             </a:extLst>
           </p:cNvPr>
@@ -9131,7 +9131,7 @@
           <p:cNvPr id="11" name="task-a-t">
             <a:extLst xmlns:a="http://schemas.openxmlformats.org/drawingml/2006/main">
               <a:ext uri="{FF2B5EF4-FFF2-40B4-BE49-F238E27FC236}">
-                <a16:creationId xmlns:a16="http://schemas.microsoft.com/office/drawing/2014/main" id="{92D6245A-B83F-4822-9181-CEC9BF4D84B1}"/>
+                <a16:creationId xmlns:a16="http://schemas.microsoft.com/office/drawing/2014/main" id="{F9450062-AF49-4568-9979-AB5FB9000B29}"/>
               </a:ext>
             </a:extLst>
           </p:cNvPr>
@@ -9193,7 +9193,7 @@
           <p:cNvPr id="12" name="task-b-t">
             <a:extLst xmlns:a="http://schemas.openxmlformats.org/drawingml/2006/main">
               <a:ext uri="{FF2B5EF4-FFF2-40B4-BE49-F238E27FC236}">
-                <a16:creationId xmlns:a16="http://schemas.microsoft.com/office/drawing/2014/main" id="{44C79AEA-26FB-4A83-8902-3720A4DACDE6}"/>
+                <a16:creationId xmlns:a16="http://schemas.microsoft.com/office/drawing/2014/main" id="{0A312DD1-158D-49FF-B511-C49DC3BF6B21}"/>
               </a:ext>
             </a:extLst>
           </p:cNvPr>
@@ -9255,7 +9255,7 @@
           <p:cNvPr id="13" name="task-c-t">
             <a:extLst xmlns:a="http://schemas.openxmlformats.org/drawingml/2006/main">
               <a:ext uri="{FF2B5EF4-FFF2-40B4-BE49-F238E27FC236}">
-                <a16:creationId xmlns:a16="http://schemas.microsoft.com/office/drawing/2014/main" id="{5CAF496F-134C-4783-AE1B-AD429EBB9114}"/>
+                <a16:creationId xmlns:a16="http://schemas.microsoft.com/office/drawing/2014/main" id="{F2988CA1-C744-4445-8374-70E4A2105624}"/>
               </a:ext>
             </a:extLst>
           </p:cNvPr>
@@ -9317,7 +9317,7 @@
           <p:cNvPr id="14" name="task-d-t">
             <a:extLst xmlns:a="http://schemas.openxmlformats.org/drawingml/2006/main">
               <a:ext uri="{FF2B5EF4-FFF2-40B4-BE49-F238E27FC236}">
-                <a16:creationId xmlns:a16="http://schemas.microsoft.com/office/drawing/2014/main" id="{E51746B3-E259-4B02-9694-53E50ECC597B}"/>
+                <a16:creationId xmlns:a16="http://schemas.microsoft.com/office/drawing/2014/main" id="{98A3555A-14D7-47F6-8FFD-9832519CB5D8}"/>
               </a:ext>
             </a:extLst>
           </p:cNvPr>
@@ -9484,7 +9484,7 @@
           <p:cNvPr id="18" name="triad-title">
             <a:extLst xmlns:a="http://schemas.openxmlformats.org/drawingml/2006/main">
               <a:ext uri="{FF2B5EF4-FFF2-40B4-BE49-F238E27FC236}">
-                <a16:creationId xmlns:a16="http://schemas.microsoft.com/office/drawing/2014/main" id="{FE80C6D8-EDE0-4F32-8E3F-995931F35BA0}"/>
+                <a16:creationId xmlns:a16="http://schemas.microsoft.com/office/drawing/2014/main" id="{B32B9868-42A0-4605-9728-FAE01E77DE59}"/>
               </a:ext>
             </a:extLst>
           </p:cNvPr>
@@ -9546,7 +9546,7 @@
           <p:cNvPr id="19" name="triad">
             <a:extLst xmlns:a="http://schemas.openxmlformats.org/drawingml/2006/main">
               <a:ext uri="{FF2B5EF4-FFF2-40B4-BE49-F238E27FC236}">
-                <a16:creationId xmlns:a16="http://schemas.microsoft.com/office/drawing/2014/main" id="{69466F3C-EAC6-43A0-8EE8-23B07AF4E11B}"/>
+                <a16:creationId xmlns:a16="http://schemas.microsoft.com/office/drawing/2014/main" id="{3D3273B0-E432-46C7-ADE8-F74B4B4967CA}"/>
               </a:ext>
             </a:extLst>
           </p:cNvPr>
@@ -9581,7 +9581,7 @@
           <p:cNvPr id="20" name="triad-copy">
             <a:extLst xmlns:a="http://schemas.openxmlformats.org/drawingml/2006/main">
               <a:ext uri="{FF2B5EF4-FFF2-40B4-BE49-F238E27FC236}">
-                <a16:creationId xmlns:a16="http://schemas.microsoft.com/office/drawing/2014/main" id="{AD90AD6F-C057-47F3-9C08-69487F06F3D9}"/>
+                <a16:creationId xmlns:a16="http://schemas.microsoft.com/office/drawing/2014/main" id="{225BFD28-1D2A-4F2C-B57A-FF1A109BCCF7}"/>
               </a:ext>
             </a:extLst>
           </p:cNvPr>
@@ -9697,7 +9697,7 @@
           <p:cNvPr id="21" name="task-metric-surface">
             <a:extLst xmlns:a="http://schemas.openxmlformats.org/drawingml/2006/main">
               <a:ext uri="{FF2B5EF4-FFF2-40B4-BE49-F238E27FC236}">
-                <a16:creationId xmlns:a16="http://schemas.microsoft.com/office/drawing/2014/main" id="{97B405BC-16EB-43EC-B4C3-3371533EE0BF}"/>
+                <a16:creationId xmlns:a16="http://schemas.microsoft.com/office/drawing/2014/main" id="{8EDD8CD7-CE17-4CE0-BBBA-7C8AA45D0A1E}"/>
               </a:ext>
             </a:extLst>
           </p:cNvPr>
@@ -9732,7 +9732,7 @@
           <p:cNvPr id="22" name="task-metric-value">
             <a:extLst xmlns:a="http://schemas.openxmlformats.org/drawingml/2006/main">
               <a:ext uri="{FF2B5EF4-FFF2-40B4-BE49-F238E27FC236}">
-                <a16:creationId xmlns:a16="http://schemas.microsoft.com/office/drawing/2014/main" id="{6BEB189E-B820-4F3C-B4AF-624AAB7FDBA7}"/>
+                <a16:creationId xmlns:a16="http://schemas.microsoft.com/office/drawing/2014/main" id="{AC1B6CB1-7916-49B8-927A-437151BA5F65}"/>
               </a:ext>
             </a:extLst>
           </p:cNvPr>
@@ -9794,7 +9794,7 @@
           <p:cNvPr id="23" name="task-metric-label">
             <a:extLst xmlns:a="http://schemas.openxmlformats.org/drawingml/2006/main">
               <a:ext uri="{FF2B5EF4-FFF2-40B4-BE49-F238E27FC236}">
-                <a16:creationId xmlns:a16="http://schemas.microsoft.com/office/drawing/2014/main" id="{91E07B86-8E5E-4CB6-926E-83DACD3FA391}"/>
+                <a16:creationId xmlns:a16="http://schemas.microsoft.com/office/drawing/2014/main" id="{96AD7531-C29D-4818-99E1-FB2F5D87A0DC}"/>
               </a:ext>
             </a:extLst>
           </p:cNvPr>
@@ -9856,7 +9856,7 @@
           <p:cNvPr id="24" name="task-metric2-surface">
             <a:extLst xmlns:a="http://schemas.openxmlformats.org/drawingml/2006/main">
               <a:ext uri="{FF2B5EF4-FFF2-40B4-BE49-F238E27FC236}">
-                <a16:creationId xmlns:a16="http://schemas.microsoft.com/office/drawing/2014/main" id="{BD3B3E9A-0ECF-4B86-B8D9-E208E7C7D272}"/>
+                <a16:creationId xmlns:a16="http://schemas.microsoft.com/office/drawing/2014/main" id="{0690E0C1-A0B3-4CB2-9CFA-B471626926FC}"/>
               </a:ext>
             </a:extLst>
           </p:cNvPr>
@@ -9891,7 +9891,7 @@
           <p:cNvPr id="25" name="task-metric2-value">
             <a:extLst xmlns:a="http://schemas.openxmlformats.org/drawingml/2006/main">
               <a:ext uri="{FF2B5EF4-FFF2-40B4-BE49-F238E27FC236}">
-                <a16:creationId xmlns:a16="http://schemas.microsoft.com/office/drawing/2014/main" id="{7BF824A6-CE77-4A02-8C7B-A6BAF69E4DDF}"/>
+                <a16:creationId xmlns:a16="http://schemas.microsoft.com/office/drawing/2014/main" id="{B44BDFB4-4BA9-48D7-AE63-70C8C1D7F12A}"/>
               </a:ext>
             </a:extLst>
           </p:cNvPr>
@@ -9953,7 +9953,7 @@
           <p:cNvPr id="26" name="task-metric2-label">
             <a:extLst xmlns:a="http://schemas.openxmlformats.org/drawingml/2006/main">
               <a:ext uri="{FF2B5EF4-FFF2-40B4-BE49-F238E27FC236}">
-                <a16:creationId xmlns:a16="http://schemas.microsoft.com/office/drawing/2014/main" id="{14C02EFE-9D32-411D-ADA1-C4FDD3AE54FD}"/>
+                <a16:creationId xmlns:a16="http://schemas.microsoft.com/office/drawing/2014/main" id="{7FCDAC5F-29E6-4486-AE9D-52A9C8F03CBD}"/>
               </a:ext>
             </a:extLst>
           </p:cNvPr>
@@ -10015,7 +10015,7 @@
           <p:cNvPr id="27" name="task-note">
             <a:extLst xmlns:a="http://schemas.openxmlformats.org/drawingml/2006/main">
               <a:ext uri="{FF2B5EF4-FFF2-40B4-BE49-F238E27FC236}">
-                <a16:creationId xmlns:a16="http://schemas.microsoft.com/office/drawing/2014/main" id="{B3F6C56D-2A4C-475E-BBD2-2A37D6B71B07}"/>
+                <a16:creationId xmlns:a16="http://schemas.microsoft.com/office/drawing/2014/main" id="{95AF2F99-23CA-42E7-9C3A-ADE911175FBF}"/>
               </a:ext>
             </a:extLst>
           </p:cNvPr>
@@ -10075,7 +10075,7 @@
     </p:spTree>
     <p:extLst>
       <p:ext uri="{BB962C8B-B14F-4D97-AF65-F5344CB8AC3E}">
-        <p14:creationId xmlns:p14="http://schemas.microsoft.com/office/powerpoint/2010/main" val="197828009"/>
+        <p14:creationId xmlns:p14="http://schemas.microsoft.com/office/powerpoint/2010/main" val="1623068368"/>
       </p:ext>
     </p:extLst>
   </p:cSld>
@@ -10106,7 +10106,7 @@
           <p:cNvPr id="21" name="kicker">
             <a:extLst xmlns:a="http://schemas.openxmlformats.org/drawingml/2006/main">
               <a:ext uri="{FF2B5EF4-FFF2-40B4-BE49-F238E27FC236}">
-                <a16:creationId xmlns:a16="http://schemas.microsoft.com/office/drawing/2014/main" id="{38497F07-DD3C-415F-91F6-3C697FBF2AEE}"/>
+                <a16:creationId xmlns:a16="http://schemas.microsoft.com/office/drawing/2014/main" id="{036FE9A9-F879-4C4D-816D-B647F56FA4E5}"/>
               </a:ext>
             </a:extLst>
           </p:cNvPr>
@@ -10168,7 +10168,7 @@
           <p:cNvPr id="2" name="title">
             <a:extLst xmlns:a="http://schemas.openxmlformats.org/drawingml/2006/main">
               <a:ext uri="{FF2B5EF4-FFF2-40B4-BE49-F238E27FC236}">
-                <a16:creationId xmlns:a16="http://schemas.microsoft.com/office/drawing/2014/main" id="{554F3E81-26EF-4ABF-A364-093F4D86FA0F}"/>
+                <a16:creationId xmlns:a16="http://schemas.microsoft.com/office/drawing/2014/main" id="{668C7B32-05D3-4683-B5D0-0460BFAD16D2}"/>
               </a:ext>
             </a:extLst>
           </p:cNvPr>
@@ -10230,7 +10230,7 @@
           <p:cNvPr id="3" name="title-rule">
             <a:extLst xmlns:a="http://schemas.openxmlformats.org/drawingml/2006/main">
               <a:ext uri="{FF2B5EF4-FFF2-40B4-BE49-F238E27FC236}">
-                <a16:creationId xmlns:a16="http://schemas.microsoft.com/office/drawing/2014/main" id="{0F4F63E0-A2B5-4814-BB08-6894F4137432}"/>
+                <a16:creationId xmlns:a16="http://schemas.microsoft.com/office/drawing/2014/main" id="{D853080E-19CE-4540-853F-0A3EC89DA221}"/>
               </a:ext>
             </a:extLst>
           </p:cNvPr>
@@ -10263,7 +10263,7 @@
           <p:cNvPr id="4" name="footer-source">
             <a:extLst xmlns:a="http://schemas.openxmlformats.org/drawingml/2006/main">
               <a:ext uri="{FF2B5EF4-FFF2-40B4-BE49-F238E27FC236}">
-                <a16:creationId xmlns:a16="http://schemas.microsoft.com/office/drawing/2014/main" id="{7B36CE3A-4452-4997-9D92-6336822D38F0}"/>
+                <a16:creationId xmlns:a16="http://schemas.microsoft.com/office/drawing/2014/main" id="{3A8703CA-8DC5-4F1F-ACC0-82823EF9F94E}"/>
               </a:ext>
             </a:extLst>
           </p:cNvPr>
@@ -10325,7 +10325,7 @@
           <p:cNvPr id="5" name="footer-page">
             <a:extLst xmlns:a="http://schemas.openxmlformats.org/drawingml/2006/main">
               <a:ext uri="{FF2B5EF4-FFF2-40B4-BE49-F238E27FC236}">
-                <a16:creationId xmlns:a16="http://schemas.microsoft.com/office/drawing/2014/main" id="{C8FFA527-C123-4D30-BD3B-953E608151E2}"/>
+                <a16:creationId xmlns:a16="http://schemas.microsoft.com/office/drawing/2014/main" id="{B5D6830F-14CB-458E-8395-4A432240B8B6}"/>
               </a:ext>
             </a:extLst>
           </p:cNvPr>
@@ -10387,7 +10387,7 @@
           <p:cNvPr id="6" name="lead">
             <a:extLst xmlns:a="http://schemas.openxmlformats.org/drawingml/2006/main">
               <a:ext uri="{FF2B5EF4-FFF2-40B4-BE49-F238E27FC236}">
-                <a16:creationId xmlns:a16="http://schemas.microsoft.com/office/drawing/2014/main" id="{02A04779-0FF2-41E5-882C-5342499ACBFC}"/>
+                <a16:creationId xmlns:a16="http://schemas.microsoft.com/office/drawing/2014/main" id="{6DF59D8E-B865-48A8-9A54-20054BC8E193}"/>
               </a:ext>
             </a:extLst>
           </p:cNvPr>
@@ -10449,7 +10449,7 @@
           <p:cNvPr id="7" name="vr-source">
             <a:extLst xmlns:a="http://schemas.openxmlformats.org/drawingml/2006/main">
               <a:ext uri="{FF2B5EF4-FFF2-40B4-BE49-F238E27FC236}">
-                <a16:creationId xmlns:a16="http://schemas.microsoft.com/office/drawing/2014/main" id="{3C2FA56B-227F-4BCA-98A0-878158E9622B}"/>
+                <a16:creationId xmlns:a16="http://schemas.microsoft.com/office/drawing/2014/main" id="{11C63772-EC48-46DA-B495-E15F24D309A7}"/>
               </a:ext>
             </a:extLst>
           </p:cNvPr>
@@ -10484,7 +10484,7 @@
           <p:cNvPr id="8" name="vr-source-num">
             <a:extLst xmlns:a="http://schemas.openxmlformats.org/drawingml/2006/main">
               <a:ext uri="{FF2B5EF4-FFF2-40B4-BE49-F238E27FC236}">
-                <a16:creationId xmlns:a16="http://schemas.microsoft.com/office/drawing/2014/main" id="{CAB265A1-2F17-4F07-AF33-A8EE47A90EB4}"/>
+                <a16:creationId xmlns:a16="http://schemas.microsoft.com/office/drawing/2014/main" id="{D9A55132-90CB-4603-B6BD-97B17474DCAC}"/>
               </a:ext>
             </a:extLst>
           </p:cNvPr>
@@ -10546,7 +10546,7 @@
           <p:cNvPr id="9" name="vr-source-label">
             <a:extLst xmlns:a="http://schemas.openxmlformats.org/drawingml/2006/main">
               <a:ext uri="{FF2B5EF4-FFF2-40B4-BE49-F238E27FC236}">
-                <a16:creationId xmlns:a16="http://schemas.microsoft.com/office/drawing/2014/main" id="{396CA7F9-38AD-4733-A821-E0BB665DBBF7}"/>
+                <a16:creationId xmlns:a16="http://schemas.microsoft.com/office/drawing/2014/main" id="{3C9B8579-BB73-43DC-BDAF-8BFDEAD1318A}"/>
               </a:ext>
             </a:extLst>
           </p:cNvPr>
@@ -10635,7 +10635,7 @@
           <p:cNvPr id="10" name="vr-core">
             <a:extLst xmlns:a="http://schemas.openxmlformats.org/drawingml/2006/main">
               <a:ext uri="{FF2B5EF4-FFF2-40B4-BE49-F238E27FC236}">
-                <a16:creationId xmlns:a16="http://schemas.microsoft.com/office/drawing/2014/main" id="{3281CA66-7FDA-47D9-8921-4E09F48D7C1D}"/>
+                <a16:creationId xmlns:a16="http://schemas.microsoft.com/office/drawing/2014/main" id="{CE210EF3-91C6-4D9B-B40F-F7CDD464800B}"/>
               </a:ext>
             </a:extLst>
           </p:cNvPr>
@@ -10668,7 +10668,7 @@
           <p:cNvPr id="11" name="vr-core-title">
             <a:extLst xmlns:a="http://schemas.openxmlformats.org/drawingml/2006/main">
               <a:ext uri="{FF2B5EF4-FFF2-40B4-BE49-F238E27FC236}">
-                <a16:creationId xmlns:a16="http://schemas.microsoft.com/office/drawing/2014/main" id="{D8485F08-4744-4477-8A11-5AA9F033ADA8}"/>
+                <a16:creationId xmlns:a16="http://schemas.microsoft.com/office/drawing/2014/main" id="{BBB50771-43BF-4A66-BEC2-A89FA4DB34F1}"/>
               </a:ext>
             </a:extLst>
           </p:cNvPr>
@@ -10730,7 +10730,7 @@
           <p:cNvPr id="12" name="vr-core-copy">
             <a:extLst xmlns:a="http://schemas.openxmlformats.org/drawingml/2006/main">
               <a:ext uri="{FF2B5EF4-FFF2-40B4-BE49-F238E27FC236}">
-                <a16:creationId xmlns:a16="http://schemas.microsoft.com/office/drawing/2014/main" id="{19675DEC-59C4-4D83-8C7E-5F155E2C6718}"/>
+                <a16:creationId xmlns:a16="http://schemas.microsoft.com/office/drawing/2014/main" id="{086C6556-2141-46C7-8965-EADACC76BC88}"/>
               </a:ext>
             </a:extLst>
           </p:cNvPr>
@@ -10819,7 +10819,7 @@
           <p:cNvPr id="13" name="vr-use">
             <a:extLst xmlns:a="http://schemas.openxmlformats.org/drawingml/2006/main">
               <a:ext uri="{FF2B5EF4-FFF2-40B4-BE49-F238E27FC236}">
-                <a16:creationId xmlns:a16="http://schemas.microsoft.com/office/drawing/2014/main" id="{CB8E7ABA-8CC3-4881-BAC5-69E53481BD50}"/>
+                <a16:creationId xmlns:a16="http://schemas.microsoft.com/office/drawing/2014/main" id="{F3075E04-472A-4F34-8CC3-D02917B7DC05}"/>
               </a:ext>
             </a:extLst>
           </p:cNvPr>
@@ -10854,7 +10854,7 @@
           <p:cNvPr id="14" name="vr-use-title">
             <a:extLst xmlns:a="http://schemas.openxmlformats.org/drawingml/2006/main">
               <a:ext uri="{FF2B5EF4-FFF2-40B4-BE49-F238E27FC236}">
-                <a16:creationId xmlns:a16="http://schemas.microsoft.com/office/drawing/2014/main" id="{47F76C7D-1867-4DEF-ABC0-227A646F1B34}"/>
+                <a16:creationId xmlns:a16="http://schemas.microsoft.com/office/drawing/2014/main" id="{1F7F4D4C-A70F-4779-BA0B-DD5A6D910D69}"/>
               </a:ext>
             </a:extLst>
           </p:cNvPr>
@@ -10916,7 +10916,7 @@
           <p:cNvPr id="15" name="vr-use-copy">
             <a:extLst xmlns:a="http://schemas.openxmlformats.org/drawingml/2006/main">
               <a:ext uri="{FF2B5EF4-FFF2-40B4-BE49-F238E27FC236}">
-                <a16:creationId xmlns:a16="http://schemas.microsoft.com/office/drawing/2014/main" id="{FB6479B0-C174-4602-81DA-29332773C424}"/>
+                <a16:creationId xmlns:a16="http://schemas.microsoft.com/office/drawing/2014/main" id="{C5130D7E-BB92-4B36-9F4F-14E1F9729320}"/>
               </a:ext>
             </a:extLst>
           </p:cNvPr>
@@ -11057,7 +11057,7 @@
           <p:cNvPr id="18" name="vr-awards">
             <a:extLst xmlns:a="http://schemas.openxmlformats.org/drawingml/2006/main">
               <a:ext uri="{FF2B5EF4-FFF2-40B4-BE49-F238E27FC236}">
-                <a16:creationId xmlns:a16="http://schemas.microsoft.com/office/drawing/2014/main" id="{18204A2E-93C2-462B-9FC5-BDCD8DE29BB7}"/>
+                <a16:creationId xmlns:a16="http://schemas.microsoft.com/office/drawing/2014/main" id="{D6909B07-BC78-4190-AE8C-FC91A4191805}"/>
               </a:ext>
             </a:extLst>
           </p:cNvPr>
@@ -11092,7 +11092,7 @@
           <p:cNvPr id="19" name="vr-awards-copy">
             <a:extLst xmlns:a="http://schemas.openxmlformats.org/drawingml/2006/main">
               <a:ext uri="{FF2B5EF4-FFF2-40B4-BE49-F238E27FC236}">
-                <a16:creationId xmlns:a16="http://schemas.microsoft.com/office/drawing/2014/main" id="{192FB1C6-CA15-40C9-8FEA-D52DFAB113C1}"/>
+                <a16:creationId xmlns:a16="http://schemas.microsoft.com/office/drawing/2014/main" id="{757CEA9A-940A-4F41-BDA8-FA8DE0645C9D}"/>
               </a:ext>
             </a:extLst>
           </p:cNvPr>
@@ -11154,7 +11154,7 @@
           <p:cNvPr id="20" name="vr-note">
             <a:extLst xmlns:a="http://schemas.openxmlformats.org/drawingml/2006/main">
               <a:ext uri="{FF2B5EF4-FFF2-40B4-BE49-F238E27FC236}">
-                <a16:creationId xmlns:a16="http://schemas.microsoft.com/office/drawing/2014/main" id="{EBFCDAAC-2CB5-43E7-9BD5-6FDBFE63C707}"/>
+                <a16:creationId xmlns:a16="http://schemas.microsoft.com/office/drawing/2014/main" id="{EBD83328-D6FE-440A-BB64-8DD7EAD0CA30}"/>
               </a:ext>
             </a:extLst>
           </p:cNvPr>
@@ -11214,7 +11214,7 @@
     </p:spTree>
     <p:extLst>
       <p:ext uri="{BB962C8B-B14F-4D97-AF65-F5344CB8AC3E}">
-        <p14:creationId xmlns:p14="http://schemas.microsoft.com/office/powerpoint/2010/main" val="1748594160"/>
+        <p14:creationId xmlns:p14="http://schemas.microsoft.com/office/powerpoint/2010/main" val="1691012316"/>
       </p:ext>
     </p:extLst>
   </p:cSld>
@@ -11245,7 +11245,7 @@
           <p:cNvPr id="21" name="kicker">
             <a:extLst xmlns:a="http://schemas.openxmlformats.org/drawingml/2006/main">
               <a:ext uri="{FF2B5EF4-FFF2-40B4-BE49-F238E27FC236}">
-                <a16:creationId xmlns:a16="http://schemas.microsoft.com/office/drawing/2014/main" id="{AFB0D9B0-99B1-401C-A103-FA4060B35BB1}"/>
+                <a16:creationId xmlns:a16="http://schemas.microsoft.com/office/drawing/2014/main" id="{F2298706-BFF7-4526-B22F-CEDB6FF7361B}"/>
               </a:ext>
             </a:extLst>
           </p:cNvPr>
@@ -11307,7 +11307,7 @@
           <p:cNvPr id="2" name="title">
             <a:extLst xmlns:a="http://schemas.openxmlformats.org/drawingml/2006/main">
               <a:ext uri="{FF2B5EF4-FFF2-40B4-BE49-F238E27FC236}">
-                <a16:creationId xmlns:a16="http://schemas.microsoft.com/office/drawing/2014/main" id="{8446FF86-9C0C-45CA-8B5B-6C2803576339}"/>
+                <a16:creationId xmlns:a16="http://schemas.microsoft.com/office/drawing/2014/main" id="{6E2728BC-8301-431F-956D-CF5408E425AD}"/>
               </a:ext>
             </a:extLst>
           </p:cNvPr>
@@ -11369,7 +11369,7 @@
           <p:cNvPr id="3" name="title-rule">
             <a:extLst xmlns:a="http://schemas.openxmlformats.org/drawingml/2006/main">
               <a:ext uri="{FF2B5EF4-FFF2-40B4-BE49-F238E27FC236}">
-                <a16:creationId xmlns:a16="http://schemas.microsoft.com/office/drawing/2014/main" id="{34B5003E-4F0F-41DB-AE08-35D9F843A3FF}"/>
+                <a16:creationId xmlns:a16="http://schemas.microsoft.com/office/drawing/2014/main" id="{3DDD572C-6A5E-4225-9226-1372D06634CC}"/>
               </a:ext>
             </a:extLst>
           </p:cNvPr>
@@ -11402,7 +11402,7 @@
           <p:cNvPr id="4" name="footer-source">
             <a:extLst xmlns:a="http://schemas.openxmlformats.org/drawingml/2006/main">
               <a:ext uri="{FF2B5EF4-FFF2-40B4-BE49-F238E27FC236}">
-                <a16:creationId xmlns:a16="http://schemas.microsoft.com/office/drawing/2014/main" id="{DCAAAC65-3680-493C-8E59-5DD2380C7005}"/>
+                <a16:creationId xmlns:a16="http://schemas.microsoft.com/office/drawing/2014/main" id="{17130D69-A507-4520-84F8-39072DDA303C}"/>
               </a:ext>
             </a:extLst>
           </p:cNvPr>
@@ -11464,7 +11464,7 @@
           <p:cNvPr id="5" name="footer-page">
             <a:extLst xmlns:a="http://schemas.openxmlformats.org/drawingml/2006/main">
               <a:ext uri="{FF2B5EF4-FFF2-40B4-BE49-F238E27FC236}">
-                <a16:creationId xmlns:a16="http://schemas.microsoft.com/office/drawing/2014/main" id="{4716A2CC-A2D7-455E-A6AD-3FDEEE7C02D0}"/>
+                <a16:creationId xmlns:a16="http://schemas.microsoft.com/office/drawing/2014/main" id="{974F493D-09BA-4FC7-A836-25F3816F4F4F}"/>
               </a:ext>
             </a:extLst>
           </p:cNvPr>
@@ -11526,7 +11526,7 @@
           <p:cNvPr id="6" name="lead">
             <a:extLst xmlns:a="http://schemas.openxmlformats.org/drawingml/2006/main">
               <a:ext uri="{FF2B5EF4-FFF2-40B4-BE49-F238E27FC236}">
-                <a16:creationId xmlns:a16="http://schemas.microsoft.com/office/drawing/2014/main" id="{0A9E9F8B-988B-4F7A-B645-73EC5292F84D}"/>
+                <a16:creationId xmlns:a16="http://schemas.microsoft.com/office/drawing/2014/main" id="{8EF1B378-B157-4B80-BB9E-76869A7F3BF8}"/>
               </a:ext>
             </a:extLst>
           </p:cNvPr>
@@ -11588,7 +11588,7 @@
           <p:cNvPr id="7" name="speak-team">
             <a:extLst xmlns:a="http://schemas.openxmlformats.org/drawingml/2006/main">
               <a:ext uri="{FF2B5EF4-FFF2-40B4-BE49-F238E27FC236}">
-                <a16:creationId xmlns:a16="http://schemas.microsoft.com/office/drawing/2014/main" id="{913604AA-5A43-4C78-A155-1EB743E64C1B}"/>
+                <a16:creationId xmlns:a16="http://schemas.microsoft.com/office/drawing/2014/main" id="{DAE95A2E-5156-4A2D-9521-2B5375521E91}"/>
               </a:ext>
             </a:extLst>
           </p:cNvPr>
@@ -11623,7 +11623,7 @@
           <p:cNvPr id="8" name="speak-team-num">
             <a:extLst xmlns:a="http://schemas.openxmlformats.org/drawingml/2006/main">
               <a:ext uri="{FF2B5EF4-FFF2-40B4-BE49-F238E27FC236}">
-                <a16:creationId xmlns:a16="http://schemas.microsoft.com/office/drawing/2014/main" id="{D70CD0EF-D308-4A0A-A77D-C621A1E2562C}"/>
+                <a16:creationId xmlns:a16="http://schemas.microsoft.com/office/drawing/2014/main" id="{A34B849F-5806-4565-A98D-623A34BDA37B}"/>
               </a:ext>
             </a:extLst>
           </p:cNvPr>
@@ -11685,7 +11685,7 @@
           <p:cNvPr id="9" name="speak-team-label">
             <a:extLst xmlns:a="http://schemas.openxmlformats.org/drawingml/2006/main">
               <a:ext uri="{FF2B5EF4-FFF2-40B4-BE49-F238E27FC236}">
-                <a16:creationId xmlns:a16="http://schemas.microsoft.com/office/drawing/2014/main" id="{D31CBFB6-9BEE-4CDB-B80D-9AC5202B3573}"/>
+                <a16:creationId xmlns:a16="http://schemas.microsoft.com/office/drawing/2014/main" id="{E0E8285F-5C7A-47E2-B3FA-A7CFB7FAEBCE}"/>
               </a:ext>
             </a:extLst>
           </p:cNvPr>
@@ -11774,7 +11774,7 @@
           <p:cNvPr id="10" name="speak-course">
             <a:extLst xmlns:a="http://schemas.openxmlformats.org/drawingml/2006/main">
               <a:ext uri="{FF2B5EF4-FFF2-40B4-BE49-F238E27FC236}">
-                <a16:creationId xmlns:a16="http://schemas.microsoft.com/office/drawing/2014/main" id="{A3AF0CB8-06A8-402A-9BD0-401F50C50FC8}"/>
+                <a16:creationId xmlns:a16="http://schemas.microsoft.com/office/drawing/2014/main" id="{A717FD2D-EA24-49DB-9C9D-974E6FDF951F}"/>
               </a:ext>
             </a:extLst>
           </p:cNvPr>
@@ -11807,7 +11807,7 @@
           <p:cNvPr id="11" name="speak-course-title">
             <a:extLst xmlns:a="http://schemas.openxmlformats.org/drawingml/2006/main">
               <a:ext uri="{FF2B5EF4-FFF2-40B4-BE49-F238E27FC236}">
-                <a16:creationId xmlns:a16="http://schemas.microsoft.com/office/drawing/2014/main" id="{7E9C9C7B-A978-4506-8646-CABC845BB742}"/>
+                <a16:creationId xmlns:a16="http://schemas.microsoft.com/office/drawing/2014/main" id="{6C5B8EB5-BB16-4603-B40D-FC8954AA1C4D}"/>
               </a:ext>
             </a:extLst>
           </p:cNvPr>
@@ -11869,7 +11869,7 @@
           <p:cNvPr id="12" name="speak-course-copy">
             <a:extLst xmlns:a="http://schemas.openxmlformats.org/drawingml/2006/main">
               <a:ext uri="{FF2B5EF4-FFF2-40B4-BE49-F238E27FC236}">
-                <a16:creationId xmlns:a16="http://schemas.microsoft.com/office/drawing/2014/main" id="{3D390DB9-5D17-4CCD-BAB9-0E25F343E33A}"/>
+                <a16:creationId xmlns:a16="http://schemas.microsoft.com/office/drawing/2014/main" id="{1BCAB58F-3C4A-41EE-8C56-E02A87A97B21}"/>
               </a:ext>
             </a:extLst>
           </p:cNvPr>
@@ -11958,7 +11958,7 @@
           <p:cNvPr id="13" name="speak-reach">
             <a:extLst xmlns:a="http://schemas.openxmlformats.org/drawingml/2006/main">
               <a:ext uri="{FF2B5EF4-FFF2-40B4-BE49-F238E27FC236}">
-                <a16:creationId xmlns:a16="http://schemas.microsoft.com/office/drawing/2014/main" id="{C6545516-12E9-4EF7-9DE6-2253DF039A03}"/>
+                <a16:creationId xmlns:a16="http://schemas.microsoft.com/office/drawing/2014/main" id="{3583B4A3-C6F2-4F08-BFAB-2F2E756B7D98}"/>
               </a:ext>
             </a:extLst>
           </p:cNvPr>
@@ -11993,7 +11993,7 @@
           <p:cNvPr id="14" name="speak-reach-num">
             <a:extLst xmlns:a="http://schemas.openxmlformats.org/drawingml/2006/main">
               <a:ext uri="{FF2B5EF4-FFF2-40B4-BE49-F238E27FC236}">
-                <a16:creationId xmlns:a16="http://schemas.microsoft.com/office/drawing/2014/main" id="{86ED0687-C860-4368-B6DA-D5C76BD27C85}"/>
+                <a16:creationId xmlns:a16="http://schemas.microsoft.com/office/drawing/2014/main" id="{5B98F790-66D1-4C89-86DE-F0760A53810D}"/>
               </a:ext>
             </a:extLst>
           </p:cNvPr>
@@ -12055,7 +12055,7 @@
           <p:cNvPr id="15" name="speak-reach-label">
             <a:extLst xmlns:a="http://schemas.openxmlformats.org/drawingml/2006/main">
               <a:ext uri="{FF2B5EF4-FFF2-40B4-BE49-F238E27FC236}">
-                <a16:creationId xmlns:a16="http://schemas.microsoft.com/office/drawing/2014/main" id="{B1B28FE3-8C1D-4A40-BCE0-2237EEA63A80}"/>
+                <a16:creationId xmlns:a16="http://schemas.microsoft.com/office/drawing/2014/main" id="{5F751C8E-5EB8-47A5-A284-B347AB8F39FE}"/>
               </a:ext>
             </a:extLst>
           </p:cNvPr>
@@ -12196,7 +12196,7 @@
           <p:cNvPr id="18" name="speak-award">
             <a:extLst xmlns:a="http://schemas.openxmlformats.org/drawingml/2006/main">
               <a:ext uri="{FF2B5EF4-FFF2-40B4-BE49-F238E27FC236}">
-                <a16:creationId xmlns:a16="http://schemas.microsoft.com/office/drawing/2014/main" id="{FAFA0CB0-0CE9-4466-8D73-EBD625CF574C}"/>
+                <a16:creationId xmlns:a16="http://schemas.microsoft.com/office/drawing/2014/main" id="{3D7A9E1F-31EF-42E0-8D35-CF2A05F4579B}"/>
               </a:ext>
             </a:extLst>
           </p:cNvPr>
@@ -12231,7 +12231,7 @@
           <p:cNvPr id="19" name="speak-award-copy">
             <a:extLst xmlns:a="http://schemas.openxmlformats.org/drawingml/2006/main">
               <a:ext uri="{FF2B5EF4-FFF2-40B4-BE49-F238E27FC236}">
-                <a16:creationId xmlns:a16="http://schemas.microsoft.com/office/drawing/2014/main" id="{873D087B-840E-4416-8523-3E7597D02773}"/>
+                <a16:creationId xmlns:a16="http://schemas.microsoft.com/office/drawing/2014/main" id="{B1342A22-87C3-4CFF-A328-3D626F1C00A7}"/>
               </a:ext>
             </a:extLst>
           </p:cNvPr>
@@ -12293,7 +12293,7 @@
           <p:cNvPr id="20" name="speak-note">
             <a:extLst xmlns:a="http://schemas.openxmlformats.org/drawingml/2006/main">
               <a:ext uri="{FF2B5EF4-FFF2-40B4-BE49-F238E27FC236}">
-                <a16:creationId xmlns:a16="http://schemas.microsoft.com/office/drawing/2014/main" id="{0DC43060-1EB4-4B5E-AD6A-E7D0E3A4FBA7}"/>
+                <a16:creationId xmlns:a16="http://schemas.microsoft.com/office/drawing/2014/main" id="{3A7D19A3-BCA5-47CF-81B6-47A817931E5C}"/>
               </a:ext>
             </a:extLst>
           </p:cNvPr>
@@ -12353,7 +12353,7 @@
     </p:spTree>
     <p:extLst>
       <p:ext uri="{BB962C8B-B14F-4D97-AF65-F5344CB8AC3E}">
-        <p14:creationId xmlns:p14="http://schemas.microsoft.com/office/powerpoint/2010/main" val="1620698118"/>
+        <p14:creationId xmlns:p14="http://schemas.microsoft.com/office/powerpoint/2010/main" val="99882242"/>
       </p:ext>
     </p:extLst>
   </p:cSld>
@@ -12384,7 +12384,7 @@
           <p:cNvPr id="20" name="kicker">
             <a:extLst xmlns:a="http://schemas.openxmlformats.org/drawingml/2006/main">
               <a:ext uri="{FF2B5EF4-FFF2-40B4-BE49-F238E27FC236}">
-                <a16:creationId xmlns:a16="http://schemas.microsoft.com/office/drawing/2014/main" id="{C5DA7FA8-5476-4E6E-B0C7-1042B961477C}"/>
+                <a16:creationId xmlns:a16="http://schemas.microsoft.com/office/drawing/2014/main" id="{7D6387F9-0F6F-435C-98E5-25F8C2C762AE}"/>
               </a:ext>
             </a:extLst>
           </p:cNvPr>
@@ -12446,7 +12446,7 @@
           <p:cNvPr id="2" name="title">
             <a:extLst xmlns:a="http://schemas.openxmlformats.org/drawingml/2006/main">
               <a:ext uri="{FF2B5EF4-FFF2-40B4-BE49-F238E27FC236}">
-                <a16:creationId xmlns:a16="http://schemas.microsoft.com/office/drawing/2014/main" id="{81C7959D-B608-422D-B026-205CC6225A58}"/>
+                <a16:creationId xmlns:a16="http://schemas.microsoft.com/office/drawing/2014/main" id="{BA872B13-3392-4AD0-A9AE-E09F0ABF42E9}"/>
               </a:ext>
             </a:extLst>
           </p:cNvPr>
@@ -12508,7 +12508,7 @@
           <p:cNvPr id="3" name="title-rule">
             <a:extLst xmlns:a="http://schemas.openxmlformats.org/drawingml/2006/main">
               <a:ext uri="{FF2B5EF4-FFF2-40B4-BE49-F238E27FC236}">
-                <a16:creationId xmlns:a16="http://schemas.microsoft.com/office/drawing/2014/main" id="{E2C6A0C6-EE1E-4053-B05F-B3904ABBC220}"/>
+                <a16:creationId xmlns:a16="http://schemas.microsoft.com/office/drawing/2014/main" id="{9DB23844-E370-4A2E-8B4A-8DADD950703F}"/>
               </a:ext>
             </a:extLst>
           </p:cNvPr>
@@ -12541,7 +12541,7 @@
           <p:cNvPr id="4" name="footer-source">
             <a:extLst xmlns:a="http://schemas.openxmlformats.org/drawingml/2006/main">
               <a:ext uri="{FF2B5EF4-FFF2-40B4-BE49-F238E27FC236}">
-                <a16:creationId xmlns:a16="http://schemas.microsoft.com/office/drawing/2014/main" id="{F2AEBD80-F726-484F-95E7-6C00FA289ADB}"/>
+                <a16:creationId xmlns:a16="http://schemas.microsoft.com/office/drawing/2014/main" id="{4BABAC9A-6A1B-40CB-8F2F-4D20568D5E9D}"/>
               </a:ext>
             </a:extLst>
           </p:cNvPr>
@@ -12603,7 +12603,7 @@
           <p:cNvPr id="5" name="footer-page">
             <a:extLst xmlns:a="http://schemas.openxmlformats.org/drawingml/2006/main">
               <a:ext uri="{FF2B5EF4-FFF2-40B4-BE49-F238E27FC236}">
-                <a16:creationId xmlns:a16="http://schemas.microsoft.com/office/drawing/2014/main" id="{82439701-E9A0-4644-8995-D5493264FE0E}"/>
+                <a16:creationId xmlns:a16="http://schemas.microsoft.com/office/drawing/2014/main" id="{1A7A11B7-F662-4644-9917-39ACE9155068}"/>
               </a:ext>
             </a:extLst>
           </p:cNvPr>
@@ -12665,7 +12665,7 @@
           <p:cNvPr id="6" name="lead">
             <a:extLst xmlns:a="http://schemas.openxmlformats.org/drawingml/2006/main">
               <a:ext uri="{FF2B5EF4-FFF2-40B4-BE49-F238E27FC236}">
-                <a16:creationId xmlns:a16="http://schemas.microsoft.com/office/drawing/2014/main" id="{142AADDB-32C7-4623-A589-083424A39F36}"/>
+                <a16:creationId xmlns:a16="http://schemas.microsoft.com/office/drawing/2014/main" id="{567BC8E5-C333-47BD-9D4E-8382277D8101}"/>
               </a:ext>
             </a:extLst>
           </p:cNvPr>
@@ -12727,7 +12727,7 @@
           <p:cNvPr id="7" name="net-left">
             <a:extLst xmlns:a="http://schemas.openxmlformats.org/drawingml/2006/main">
               <a:ext uri="{FF2B5EF4-FFF2-40B4-BE49-F238E27FC236}">
-                <a16:creationId xmlns:a16="http://schemas.microsoft.com/office/drawing/2014/main" id="{5FCFCF54-A669-49D3-9398-5134EB1F319E}"/>
+                <a16:creationId xmlns:a16="http://schemas.microsoft.com/office/drawing/2014/main" id="{5AE4063C-06EC-466E-A946-F11946CD8631}"/>
               </a:ext>
             </a:extLst>
           </p:cNvPr>
@@ -12762,7 +12762,7 @@
           <p:cNvPr id="8" name="net-left-num">
             <a:extLst xmlns:a="http://schemas.openxmlformats.org/drawingml/2006/main">
               <a:ext uri="{FF2B5EF4-FFF2-40B4-BE49-F238E27FC236}">
-                <a16:creationId xmlns:a16="http://schemas.microsoft.com/office/drawing/2014/main" id="{90469D37-A3AB-45DF-A3C1-9FF98F73212B}"/>
+                <a16:creationId xmlns:a16="http://schemas.microsoft.com/office/drawing/2014/main" id="{A89A2C77-11C1-484B-AEEB-A550AE78D467}"/>
               </a:ext>
             </a:extLst>
           </p:cNvPr>
@@ -12824,7 +12824,7 @@
           <p:cNvPr id="9" name="net-left-copy">
             <a:extLst xmlns:a="http://schemas.openxmlformats.org/drawingml/2006/main">
               <a:ext uri="{FF2B5EF4-FFF2-40B4-BE49-F238E27FC236}">
-                <a16:creationId xmlns:a16="http://schemas.microsoft.com/office/drawing/2014/main" id="{2FEB0D78-50D9-44C3-A83F-C980E9E2275A}"/>
+                <a16:creationId xmlns:a16="http://schemas.microsoft.com/office/drawing/2014/main" id="{563F5646-2927-4247-BFC0-B0FCB84C50AD}"/>
               </a:ext>
             </a:extLst>
           </p:cNvPr>
@@ -12940,7 +12940,7 @@
           <p:cNvPr id="10" name="net-hub">
             <a:extLst xmlns:a="http://schemas.openxmlformats.org/drawingml/2006/main">
               <a:ext uri="{FF2B5EF4-FFF2-40B4-BE49-F238E27FC236}">
-                <a16:creationId xmlns:a16="http://schemas.microsoft.com/office/drawing/2014/main" id="{D95BF2E0-87C2-4437-AA3F-0B45A6D6EDEA}"/>
+                <a16:creationId xmlns:a16="http://schemas.microsoft.com/office/drawing/2014/main" id="{7E015863-8F73-4DD5-82C2-E58BE53A6336}"/>
               </a:ext>
             </a:extLst>
           </p:cNvPr>
@@ -12973,7 +12973,7 @@
           <p:cNvPr id="11" name="net-hub-title">
             <a:extLst xmlns:a="http://schemas.openxmlformats.org/drawingml/2006/main">
               <a:ext uri="{FF2B5EF4-FFF2-40B4-BE49-F238E27FC236}">
-                <a16:creationId xmlns:a16="http://schemas.microsoft.com/office/drawing/2014/main" id="{822911F9-003F-4620-8AEA-2998B0D9A6AB}"/>
+                <a16:creationId xmlns:a16="http://schemas.microsoft.com/office/drawing/2014/main" id="{93799DA4-E571-4413-AF86-90447440B06A}"/>
               </a:ext>
             </a:extLst>
           </p:cNvPr>
@@ -13035,7 +13035,7 @@
           <p:cNvPr id="12" name="net-hub-copy">
             <a:extLst xmlns:a="http://schemas.openxmlformats.org/drawingml/2006/main">
               <a:ext uri="{FF2B5EF4-FFF2-40B4-BE49-F238E27FC236}">
-                <a16:creationId xmlns:a16="http://schemas.microsoft.com/office/drawing/2014/main" id="{4BF34CC8-3F49-425C-BD32-45A8A0F9AFA8}"/>
+                <a16:creationId xmlns:a16="http://schemas.microsoft.com/office/drawing/2014/main" id="{0EF7783B-DCFD-43BC-81EE-2E16C85C74FD}"/>
               </a:ext>
             </a:extLst>
           </p:cNvPr>
@@ -13097,7 +13097,7 @@
           <p:cNvPr id="13" name="net-right">
             <a:extLst xmlns:a="http://schemas.openxmlformats.org/drawingml/2006/main">
               <a:ext uri="{FF2B5EF4-FFF2-40B4-BE49-F238E27FC236}">
-                <a16:creationId xmlns:a16="http://schemas.microsoft.com/office/drawing/2014/main" id="{9BDA462B-13CC-428E-944D-19C89DE62160}"/>
+                <a16:creationId xmlns:a16="http://schemas.microsoft.com/office/drawing/2014/main" id="{80129F25-3431-4A69-A149-E94622C84FC0}"/>
               </a:ext>
             </a:extLst>
           </p:cNvPr>
@@ -13132,7 +13132,7 @@
           <p:cNvPr id="14" name="net-right-num">
             <a:extLst xmlns:a="http://schemas.openxmlformats.org/drawingml/2006/main">
               <a:ext uri="{FF2B5EF4-FFF2-40B4-BE49-F238E27FC236}">
-                <a16:creationId xmlns:a16="http://schemas.microsoft.com/office/drawing/2014/main" id="{3C6BA4DD-BEBA-4EC1-B4F6-2B32B26F864E}"/>
+                <a16:creationId xmlns:a16="http://schemas.microsoft.com/office/drawing/2014/main" id="{C72D1F0E-578C-4323-97BF-AAE0C1FFA594}"/>
               </a:ext>
             </a:extLst>
           </p:cNvPr>
@@ -13194,7 +13194,7 @@
           <p:cNvPr id="15" name="net-right-copy">
             <a:extLst xmlns:a="http://schemas.openxmlformats.org/drawingml/2006/main">
               <a:ext uri="{FF2B5EF4-FFF2-40B4-BE49-F238E27FC236}">
-                <a16:creationId xmlns:a16="http://schemas.microsoft.com/office/drawing/2014/main" id="{5C7EFDC5-46E8-4453-B7F5-55167CAFCA87}"/>
+                <a16:creationId xmlns:a16="http://schemas.microsoft.com/office/drawing/2014/main" id="{F6A6DAE5-9F60-4892-A6DB-2BB6B227E6C8}"/>
               </a:ext>
             </a:extLst>
           </p:cNvPr>
@@ -13362,7 +13362,7 @@
           <p:cNvPr id="19" name="net-note">
             <a:extLst xmlns:a="http://schemas.openxmlformats.org/drawingml/2006/main">
               <a:ext uri="{FF2B5EF4-FFF2-40B4-BE49-F238E27FC236}">
-                <a16:creationId xmlns:a16="http://schemas.microsoft.com/office/drawing/2014/main" id="{733FFBAD-ECA7-4314-8ED7-0921675A7AAC}"/>
+                <a16:creationId xmlns:a16="http://schemas.microsoft.com/office/drawing/2014/main" id="{9C266ECA-1E07-4B1C-B346-3A09877CF736}"/>
               </a:ext>
             </a:extLst>
           </p:cNvPr>
@@ -13422,7 +13422,7 @@
     </p:spTree>
     <p:extLst>
       <p:ext uri="{BB962C8B-B14F-4D97-AF65-F5344CB8AC3E}">
-        <p14:creationId xmlns:p14="http://schemas.microsoft.com/office/powerpoint/2010/main" val="506238764"/>
+        <p14:creationId xmlns:p14="http://schemas.microsoft.com/office/powerpoint/2010/main" val="589684611"/>
       </p:ext>
     </p:extLst>
   </p:cSld>
@@ -13453,7 +13453,7 @@
           <p:cNvPr id="30" name="kicker">
             <a:extLst xmlns:a="http://schemas.openxmlformats.org/drawingml/2006/main">
               <a:ext uri="{FF2B5EF4-FFF2-40B4-BE49-F238E27FC236}">
-                <a16:creationId xmlns:a16="http://schemas.microsoft.com/office/drawing/2014/main" id="{8D48E802-B907-479F-B36C-076829AAB2B9}"/>
+                <a16:creationId xmlns:a16="http://schemas.microsoft.com/office/drawing/2014/main" id="{B14B68CE-5B76-474B-87A5-CF8E4B80393C}"/>
               </a:ext>
             </a:extLst>
           </p:cNvPr>
@@ -13515,7 +13515,7 @@
           <p:cNvPr id="2" name="title">
             <a:extLst xmlns:a="http://schemas.openxmlformats.org/drawingml/2006/main">
               <a:ext uri="{FF2B5EF4-FFF2-40B4-BE49-F238E27FC236}">
-                <a16:creationId xmlns:a16="http://schemas.microsoft.com/office/drawing/2014/main" id="{6D7FAE29-D3AF-431D-94C8-A82566B282D5}"/>
+                <a16:creationId xmlns:a16="http://schemas.microsoft.com/office/drawing/2014/main" id="{D34C0CAC-8C27-4DEF-9229-A7E454E34B98}"/>
               </a:ext>
             </a:extLst>
           </p:cNvPr>
@@ -13577,7 +13577,7 @@
           <p:cNvPr id="3" name="title-rule">
             <a:extLst xmlns:a="http://schemas.openxmlformats.org/drawingml/2006/main">
               <a:ext uri="{FF2B5EF4-FFF2-40B4-BE49-F238E27FC236}">
-                <a16:creationId xmlns:a16="http://schemas.microsoft.com/office/drawing/2014/main" id="{2505BB2C-4162-440A-AA0D-B407D4AB8D52}"/>
+                <a16:creationId xmlns:a16="http://schemas.microsoft.com/office/drawing/2014/main" id="{692C5F9D-2969-4DCB-924F-8655E40FAF18}"/>
               </a:ext>
             </a:extLst>
           </p:cNvPr>
@@ -13610,7 +13610,7 @@
           <p:cNvPr id="4" name="footer-source">
             <a:extLst xmlns:a="http://schemas.openxmlformats.org/drawingml/2006/main">
               <a:ext uri="{FF2B5EF4-FFF2-40B4-BE49-F238E27FC236}">
-                <a16:creationId xmlns:a16="http://schemas.microsoft.com/office/drawing/2014/main" id="{6774E334-4E55-4A0C-8D6B-6AD7FCD9063A}"/>
+                <a16:creationId xmlns:a16="http://schemas.microsoft.com/office/drawing/2014/main" id="{619CAFBA-FDF7-4072-9DAC-8299E2333B34}"/>
               </a:ext>
             </a:extLst>
           </p:cNvPr>
@@ -13672,7 +13672,7 @@
           <p:cNvPr id="5" name="footer-page">
             <a:extLst xmlns:a="http://schemas.openxmlformats.org/drawingml/2006/main">
               <a:ext uri="{FF2B5EF4-FFF2-40B4-BE49-F238E27FC236}">
-                <a16:creationId xmlns:a16="http://schemas.microsoft.com/office/drawing/2014/main" id="{D20BF413-8BB9-40F4-A70A-80589E18C6E3}"/>
+                <a16:creationId xmlns:a16="http://schemas.microsoft.com/office/drawing/2014/main" id="{0F34F664-C82F-4D4A-9CC1-88D78FD117D8}"/>
               </a:ext>
             </a:extLst>
           </p:cNvPr>
@@ -13734,7 +13734,7 @@
           <p:cNvPr id="6" name="lead">
             <a:extLst xmlns:a="http://schemas.openxmlformats.org/drawingml/2006/main">
               <a:ext uri="{FF2B5EF4-FFF2-40B4-BE49-F238E27FC236}">
-                <a16:creationId xmlns:a16="http://schemas.microsoft.com/office/drawing/2014/main" id="{93148C84-466C-4E28-97A5-8EAD3DEF61A4}"/>
+                <a16:creationId xmlns:a16="http://schemas.microsoft.com/office/drawing/2014/main" id="{BD282EE1-BF14-4798-B181-96FCEBF33187}"/>
               </a:ext>
             </a:extLst>
           </p:cNvPr>
@@ -13796,7 +13796,7 @@
           <p:cNvPr id="7" name="stage-0">
             <a:extLst xmlns:a="http://schemas.openxmlformats.org/drawingml/2006/main">
               <a:ext uri="{FF2B5EF4-FFF2-40B4-BE49-F238E27FC236}">
-                <a16:creationId xmlns:a16="http://schemas.microsoft.com/office/drawing/2014/main" id="{D7B4BC6B-27D7-4318-87EE-280D7F65A6A6}"/>
+                <a16:creationId xmlns:a16="http://schemas.microsoft.com/office/drawing/2014/main" id="{9462D0C6-852A-43C7-B76D-C4B2BA256EAE}"/>
               </a:ext>
             </a:extLst>
           </p:cNvPr>
@@ -13831,7 +13831,7 @@
           <p:cNvPr id="8" name="stage-0-num">
             <a:extLst xmlns:a="http://schemas.openxmlformats.org/drawingml/2006/main">
               <a:ext uri="{FF2B5EF4-FFF2-40B4-BE49-F238E27FC236}">
-                <a16:creationId xmlns:a16="http://schemas.microsoft.com/office/drawing/2014/main" id="{F5F2A4E0-6E6C-4C8B-976F-3111537686ED}"/>
+                <a16:creationId xmlns:a16="http://schemas.microsoft.com/office/drawing/2014/main" id="{C801A46B-5941-4E13-BDDD-6087F6E79A4D}"/>
               </a:ext>
             </a:extLst>
           </p:cNvPr>
@@ -13893,7 +13893,7 @@
           <p:cNvPr id="9" name="stage-0-title">
             <a:extLst xmlns:a="http://schemas.openxmlformats.org/drawingml/2006/main">
               <a:ext uri="{FF2B5EF4-FFF2-40B4-BE49-F238E27FC236}">
-                <a16:creationId xmlns:a16="http://schemas.microsoft.com/office/drawing/2014/main" id="{AF7D07F2-3C47-49D5-874F-7B1BE7203E30}"/>
+                <a16:creationId xmlns:a16="http://schemas.microsoft.com/office/drawing/2014/main" id="{7E0315B3-8F40-41AB-9CF1-B43BB9F50AC8}"/>
               </a:ext>
             </a:extLst>
           </p:cNvPr>
@@ -13955,7 +13955,7 @@
           <p:cNvPr id="10" name="stage-0-label">
             <a:extLst xmlns:a="http://schemas.openxmlformats.org/drawingml/2006/main">
               <a:ext uri="{FF2B5EF4-FFF2-40B4-BE49-F238E27FC236}">
-                <a16:creationId xmlns:a16="http://schemas.microsoft.com/office/drawing/2014/main" id="{E8577E84-7B75-4ACE-90AC-A3ECB64E8848}"/>
+                <a16:creationId xmlns:a16="http://schemas.microsoft.com/office/drawing/2014/main" id="{2F1D6FB2-3213-4273-B0AA-1D399E264FD6}"/>
               </a:ext>
             </a:extLst>
           </p:cNvPr>
@@ -14017,7 +14017,7 @@
           <p:cNvPr id="11" name="stage-1">
             <a:extLst xmlns:a="http://schemas.openxmlformats.org/drawingml/2006/main">
               <a:ext uri="{FF2B5EF4-FFF2-40B4-BE49-F238E27FC236}">
-                <a16:creationId xmlns:a16="http://schemas.microsoft.com/office/drawing/2014/main" id="{71C09031-FBFF-470C-92F0-410D6B62BE7C}"/>
+                <a16:creationId xmlns:a16="http://schemas.microsoft.com/office/drawing/2014/main" id="{07C9B1DD-6409-4E66-9832-5B7D821F8E41}"/>
               </a:ext>
             </a:extLst>
           </p:cNvPr>
@@ -14052,7 +14052,7 @@
           <p:cNvPr id="12" name="stage-1-num">
             <a:extLst xmlns:a="http://schemas.openxmlformats.org/drawingml/2006/main">
               <a:ext uri="{FF2B5EF4-FFF2-40B4-BE49-F238E27FC236}">
-                <a16:creationId xmlns:a16="http://schemas.microsoft.com/office/drawing/2014/main" id="{D0FE500A-1978-4C56-A74E-C4C3DCC29283}"/>
+                <a16:creationId xmlns:a16="http://schemas.microsoft.com/office/drawing/2014/main" id="{D91BA300-5BFA-42D2-9251-648FC64B0D7E}"/>
               </a:ext>
             </a:extLst>
           </p:cNvPr>
@@ -14114,7 +14114,7 @@
           <p:cNvPr id="13" name="stage-1-title">
             <a:extLst xmlns:a="http://schemas.openxmlformats.org/drawingml/2006/main">
               <a:ext uri="{FF2B5EF4-FFF2-40B4-BE49-F238E27FC236}">
-                <a16:creationId xmlns:a16="http://schemas.microsoft.com/office/drawing/2014/main" id="{892A1F86-4EFE-4543-BEAB-2DA004E752D8}"/>
+                <a16:creationId xmlns:a16="http://schemas.microsoft.com/office/drawing/2014/main" id="{A8439688-648E-4307-BDDC-E76A2628A45B}"/>
               </a:ext>
             </a:extLst>
           </p:cNvPr>
@@ -14176,7 +14176,7 @@
           <p:cNvPr id="14" name="stage-1-label">
             <a:extLst xmlns:a="http://schemas.openxmlformats.org/drawingml/2006/main">
               <a:ext uri="{FF2B5EF4-FFF2-40B4-BE49-F238E27FC236}">
-                <a16:creationId xmlns:a16="http://schemas.microsoft.com/office/drawing/2014/main" id="{CDDCC995-E134-4A5E-8E66-A070733FBEAE}"/>
+                <a16:creationId xmlns:a16="http://schemas.microsoft.com/office/drawing/2014/main" id="{3A87984B-C6A2-4740-9474-BF97C230F264}"/>
               </a:ext>
             </a:extLst>
           </p:cNvPr>
@@ -14238,7 +14238,7 @@
           <p:cNvPr id="15" name="stage-2">
             <a:extLst xmlns:a="http://schemas.openxmlformats.org/drawingml/2006/main">
               <a:ext uri="{FF2B5EF4-FFF2-40B4-BE49-F238E27FC236}">
-                <a16:creationId xmlns:a16="http://schemas.microsoft.com/office/drawing/2014/main" id="{7CC7FBDC-19D7-4602-A68E-020352D1099C}"/>
+                <a16:creationId xmlns:a16="http://schemas.microsoft.com/office/drawing/2014/main" id="{C0FF1A2C-75B3-4437-B948-5C9936976835}"/>
               </a:ext>
             </a:extLst>
           </p:cNvPr>
@@ -14273,7 +14273,7 @@
           <p:cNvPr id="16" name="stage-2-num">
             <a:extLst xmlns:a="http://schemas.openxmlformats.org/drawingml/2006/main">
               <a:ext uri="{FF2B5EF4-FFF2-40B4-BE49-F238E27FC236}">
-                <a16:creationId xmlns:a16="http://schemas.microsoft.com/office/drawing/2014/main" id="{FC5DF004-9482-46AA-9669-37CF5DE8E683}"/>
+                <a16:creationId xmlns:a16="http://schemas.microsoft.com/office/drawing/2014/main" id="{D7CB2D45-2D50-4CAB-9836-D7B693E2FF40}"/>
               </a:ext>
             </a:extLst>
           </p:cNvPr>
@@ -14335,7 +14335,7 @@
           <p:cNvPr id="17" name="stage-2-title">
             <a:extLst xmlns:a="http://schemas.openxmlformats.org/drawingml/2006/main">
               <a:ext uri="{FF2B5EF4-FFF2-40B4-BE49-F238E27FC236}">
-                <a16:creationId xmlns:a16="http://schemas.microsoft.com/office/drawing/2014/main" id="{933DAF54-50B0-494B-91DB-1D0ED1B645E0}"/>
+                <a16:creationId xmlns:a16="http://schemas.microsoft.com/office/drawing/2014/main" id="{D3C0E81C-51E5-4540-A959-A061B95CE87B}"/>
               </a:ext>
             </a:extLst>
           </p:cNvPr>
@@ -14397,7 +14397,7 @@
           <p:cNvPr id="18" name="stage-2-label">
             <a:extLst xmlns:a="http://schemas.openxmlformats.org/drawingml/2006/main">
               <a:ext uri="{FF2B5EF4-FFF2-40B4-BE49-F238E27FC236}">
-                <a16:creationId xmlns:a16="http://schemas.microsoft.com/office/drawing/2014/main" id="{6A817C00-D8FF-486F-9773-CBE9F74ED595}"/>
+                <a16:creationId xmlns:a16="http://schemas.microsoft.com/office/drawing/2014/main" id="{84A8A0B4-029C-43F0-8970-DDA75C3F9328}"/>
               </a:ext>
             </a:extLst>
           </p:cNvPr>
@@ -14459,7 +14459,7 @@
           <p:cNvPr id="19" name="stage-3">
             <a:extLst xmlns:a="http://schemas.openxmlformats.org/drawingml/2006/main">
               <a:ext uri="{FF2B5EF4-FFF2-40B4-BE49-F238E27FC236}">
-                <a16:creationId xmlns:a16="http://schemas.microsoft.com/office/drawing/2014/main" id="{5C5A37FC-BD88-4235-86A7-DBC325DF3297}"/>
+                <a16:creationId xmlns:a16="http://schemas.microsoft.com/office/drawing/2014/main" id="{A046C550-1A30-4497-AACE-E92CD6F82FAD}"/>
               </a:ext>
             </a:extLst>
           </p:cNvPr>
@@ -14492,7 +14492,7 @@
           <p:cNvPr id="20" name="stage-3-num">
             <a:extLst xmlns:a="http://schemas.openxmlformats.org/drawingml/2006/main">
               <a:ext uri="{FF2B5EF4-FFF2-40B4-BE49-F238E27FC236}">
-                <a16:creationId xmlns:a16="http://schemas.microsoft.com/office/drawing/2014/main" id="{86CA0EF0-B38B-4606-9E5A-66CC73ACE2FF}"/>
+                <a16:creationId xmlns:a16="http://schemas.microsoft.com/office/drawing/2014/main" id="{F09F72A9-2C58-4B69-AE23-1F9F1BB87ADB}"/>
               </a:ext>
             </a:extLst>
           </p:cNvPr>
@@ -14554,7 +14554,7 @@
           <p:cNvPr id="21" name="stage-3-title">
             <a:extLst xmlns:a="http://schemas.openxmlformats.org/drawingml/2006/main">
               <a:ext uri="{FF2B5EF4-FFF2-40B4-BE49-F238E27FC236}">
-                <a16:creationId xmlns:a16="http://schemas.microsoft.com/office/drawing/2014/main" id="{6C507202-9C6F-4AA6-8F1B-21A71F8D71CE}"/>
+                <a16:creationId xmlns:a16="http://schemas.microsoft.com/office/drawing/2014/main" id="{B5450B9C-2516-4C4A-8369-125124EDCDA1}"/>
               </a:ext>
             </a:extLst>
           </p:cNvPr>
@@ -14616,7 +14616,7 @@
           <p:cNvPr id="22" name="stage-3-label">
             <a:extLst xmlns:a="http://schemas.openxmlformats.org/drawingml/2006/main">
               <a:ext uri="{FF2B5EF4-FFF2-40B4-BE49-F238E27FC236}">
-                <a16:creationId xmlns:a16="http://schemas.microsoft.com/office/drawing/2014/main" id="{54A3D5A9-F7EB-4073-805E-E40B78E7FEE4}"/>
+                <a16:creationId xmlns:a16="http://schemas.microsoft.com/office/drawing/2014/main" id="{86874818-735D-40A5-B2AD-EFDC62BB35C5}"/>
               </a:ext>
             </a:extLst>
           </p:cNvPr>
@@ -14756,7 +14756,7 @@
           <p:cNvPr id="26" name="stage-support">
             <a:extLst xmlns:a="http://schemas.openxmlformats.org/drawingml/2006/main">
               <a:ext uri="{FF2B5EF4-FFF2-40B4-BE49-F238E27FC236}">
-                <a16:creationId xmlns:a16="http://schemas.microsoft.com/office/drawing/2014/main" id="{B97E88BE-6C1B-45B0-96CD-18751CBBB9FB}"/>
+                <a16:creationId xmlns:a16="http://schemas.microsoft.com/office/drawing/2014/main" id="{C6B8B209-77E6-4372-BBAD-6402DA9B6B30}"/>
               </a:ext>
             </a:extLst>
           </p:cNvPr>
@@ -14791,7 +14791,7 @@
           <p:cNvPr id="27" name="stage-support-title">
             <a:extLst xmlns:a="http://schemas.openxmlformats.org/drawingml/2006/main">
               <a:ext uri="{FF2B5EF4-FFF2-40B4-BE49-F238E27FC236}">
-                <a16:creationId xmlns:a16="http://schemas.microsoft.com/office/drawing/2014/main" id="{3B5F6B50-EB0A-4C5C-B6B5-490BC098D510}"/>
+                <a16:creationId xmlns:a16="http://schemas.microsoft.com/office/drawing/2014/main" id="{D1EDDD12-D3E9-4851-ABC0-7E7634A6A3F5}"/>
               </a:ext>
             </a:extLst>
           </p:cNvPr>
@@ -14853,7 +14853,7 @@
           <p:cNvPr id="28" name="stage-support-copy">
             <a:extLst xmlns:a="http://schemas.openxmlformats.org/drawingml/2006/main">
               <a:ext uri="{FF2B5EF4-FFF2-40B4-BE49-F238E27FC236}">
-                <a16:creationId xmlns:a16="http://schemas.microsoft.com/office/drawing/2014/main" id="{AC9302E3-2A86-4B1A-BD21-06719CA655C9}"/>
+                <a16:creationId xmlns:a16="http://schemas.microsoft.com/office/drawing/2014/main" id="{826B1325-7C28-49F2-BB83-2ED50E7149EB}"/>
               </a:ext>
             </a:extLst>
           </p:cNvPr>
@@ -14915,7 +14915,7 @@
           <p:cNvPr id="29" name="stage-note">
             <a:extLst xmlns:a="http://schemas.openxmlformats.org/drawingml/2006/main">
               <a:ext uri="{FF2B5EF4-FFF2-40B4-BE49-F238E27FC236}">
-                <a16:creationId xmlns:a16="http://schemas.microsoft.com/office/drawing/2014/main" id="{A4B2975D-B013-4B61-BFEA-603B91C16CDC}"/>
+                <a16:creationId xmlns:a16="http://schemas.microsoft.com/office/drawing/2014/main" id="{4C78B367-FBCE-4273-B7CC-DAFEDCEB37F9}"/>
               </a:ext>
             </a:extLst>
           </p:cNvPr>
@@ -14975,7 +14975,7 @@
     </p:spTree>
     <p:extLst>
       <p:ext uri="{BB962C8B-B14F-4D97-AF65-F5344CB8AC3E}">
-        <p14:creationId xmlns:p14="http://schemas.microsoft.com/office/powerpoint/2010/main" val="2094136323"/>
+        <p14:creationId xmlns:p14="http://schemas.microsoft.com/office/powerpoint/2010/main" val="992794683"/>
       </p:ext>
     </p:extLst>
   </p:cSld>

</xml_diff>